<commit_message>
chore: finalize V13 synchronization - integrated Refined V12 engine, new Gemini keys, and Agentic OS UI overhaul
</commit_message>
<xml_diff>
--- a/Agentic_Healthcare_AI_Presentation.pptx
+++ b/Agentic_Healthcare_AI_Presentation.pptx
@@ -6393,7 +6393,7 @@
         <p:spPr>
           <a:xfrm>
             <a:off x="320040" y="1691640"/>
-            <a:ext cx="2926080" cy="530352"/>
+            <a:ext cx="2926080" cy="475488"/>
           </a:xfrm>
           <a:prstGeom prst="rect">
             <a:avLst/>
@@ -6435,23 +6435,23 @@
         </p:nvSpPr>
         <p:spPr>
           <a:xfrm>
-            <a:off x="374904" y="1783080"/>
-            <a:ext cx="2834640" cy="365760"/>
-          </a:xfrm>
-          <a:prstGeom prst="rect">
-            <a:avLst/>
-          </a:prstGeom>
-          <a:noFill/>
-        </p:spPr>
-        <p:txBody>
-          <a:bodyPr wrap="square">
-            <a:spAutoFit/>
-          </a:bodyPr>
-          <a:lstStyle/>
-          <a:p>
-            <a:pPr algn="ctr"/>
-            <a:r>
-              <a:rPr sz="1200" b="0" i="0">
+            <a:off x="374904" y="1764792"/>
+            <a:ext cx="2834640" cy="347472"/>
+          </a:xfrm>
+          <a:prstGeom prst="rect">
+            <a:avLst/>
+          </a:prstGeom>
+          <a:noFill/>
+        </p:spPr>
+        <p:txBody>
+          <a:bodyPr wrap="square">
+            <a:spAutoFit/>
+          </a:bodyPr>
+          <a:lstStyle/>
+          <a:p>
+            <a:pPr algn="ctr"/>
+            <a:r>
+              <a:rPr sz="1100" b="0" i="0">
                 <a:solidFill>
                   <a:srgbClr val="FFFFFF"/>
                 </a:solidFill>
@@ -6471,7 +6471,7 @@
         <p:spPr>
           <a:xfrm>
             <a:off x="3337560" y="1691640"/>
-            <a:ext cx="2377440" cy="530352"/>
+            <a:ext cx="2377440" cy="475488"/>
           </a:xfrm>
           <a:prstGeom prst="rect">
             <a:avLst/>
@@ -6513,23 +6513,23 @@
         </p:nvSpPr>
         <p:spPr>
           <a:xfrm>
-            <a:off x="3392424" y="1783080"/>
-            <a:ext cx="2286000" cy="365760"/>
-          </a:xfrm>
-          <a:prstGeom prst="rect">
-            <a:avLst/>
-          </a:prstGeom>
-          <a:noFill/>
-        </p:spPr>
-        <p:txBody>
-          <a:bodyPr wrap="square">
-            <a:spAutoFit/>
-          </a:bodyPr>
-          <a:lstStyle/>
-          <a:p>
-            <a:pPr algn="ctr"/>
-            <a:r>
-              <a:rPr sz="1200" b="0" i="0">
+            <a:off x="3392424" y="1764792"/>
+            <a:ext cx="2286000" cy="347472"/>
+          </a:xfrm>
+          <a:prstGeom prst="rect">
+            <a:avLst/>
+          </a:prstGeom>
+          <a:noFill/>
+        </p:spPr>
+        <p:txBody>
+          <a:bodyPr wrap="square">
+            <a:spAutoFit/>
+          </a:bodyPr>
+          <a:lstStyle/>
+          <a:p>
+            <a:pPr algn="ctr"/>
+            <a:r>
+              <a:rPr sz="1100" b="0" i="0">
                 <a:solidFill>
                   <a:srgbClr val="27AE60"/>
                 </a:solidFill>
@@ -6549,7 +6549,7 @@
         <p:spPr>
           <a:xfrm>
             <a:off x="5806440" y="1691640"/>
-            <a:ext cx="1828800" cy="530352"/>
+            <a:ext cx="1828800" cy="475488"/>
           </a:xfrm>
           <a:prstGeom prst="rect">
             <a:avLst/>
@@ -6591,23 +6591,23 @@
         </p:nvSpPr>
         <p:spPr>
           <a:xfrm>
-            <a:off x="5861303" y="1783080"/>
-            <a:ext cx="1737360" cy="365760"/>
-          </a:xfrm>
-          <a:prstGeom prst="rect">
-            <a:avLst/>
-          </a:prstGeom>
-          <a:noFill/>
-        </p:spPr>
-        <p:txBody>
-          <a:bodyPr wrap="square">
-            <a:spAutoFit/>
-          </a:bodyPr>
-          <a:lstStyle/>
-          <a:p>
-            <a:pPr algn="ctr"/>
-            <a:r>
-              <a:rPr sz="1200" b="0" i="0">
+            <a:off x="5861303" y="1764792"/>
+            <a:ext cx="1737360" cy="347472"/>
+          </a:xfrm>
+          <a:prstGeom prst="rect">
+            <a:avLst/>
+          </a:prstGeom>
+          <a:noFill/>
+        </p:spPr>
+        <p:txBody>
+          <a:bodyPr wrap="square">
+            <a:spAutoFit/>
+          </a:bodyPr>
+          <a:lstStyle/>
+          <a:p>
+            <a:pPr algn="ctr"/>
+            <a:r>
+              <a:rPr sz="1100" b="0" i="0">
                 <a:solidFill>
                   <a:srgbClr val="E74C3C"/>
                 </a:solidFill>
@@ -6627,7 +6627,7 @@
         <p:spPr>
           <a:xfrm>
             <a:off x="7726679" y="1691640"/>
-            <a:ext cx="1828800" cy="530352"/>
+            <a:ext cx="1828800" cy="475488"/>
           </a:xfrm>
           <a:prstGeom prst="rect">
             <a:avLst/>
@@ -6669,23 +6669,23 @@
         </p:nvSpPr>
         <p:spPr>
           <a:xfrm>
-            <a:off x="7781544" y="1783080"/>
-            <a:ext cx="1737360" cy="365760"/>
-          </a:xfrm>
-          <a:prstGeom prst="rect">
-            <a:avLst/>
-          </a:prstGeom>
-          <a:noFill/>
-        </p:spPr>
-        <p:txBody>
-          <a:bodyPr wrap="square">
-            <a:spAutoFit/>
-          </a:bodyPr>
-          <a:lstStyle/>
-          <a:p>
-            <a:pPr algn="ctr"/>
-            <a:r>
-              <a:rPr sz="1200" b="0" i="0">
+            <a:off x="7781544" y="1764792"/>
+            <a:ext cx="1737360" cy="347472"/>
+          </a:xfrm>
+          <a:prstGeom prst="rect">
+            <a:avLst/>
+          </a:prstGeom>
+          <a:noFill/>
+        </p:spPr>
+        <p:txBody>
+          <a:bodyPr wrap="square">
+            <a:spAutoFit/>
+          </a:bodyPr>
+          <a:lstStyle/>
+          <a:p>
+            <a:pPr algn="ctr"/>
+            <a:r>
+              <a:rPr sz="1100" b="0" i="0">
                 <a:solidFill>
                   <a:srgbClr val="E74C3C"/>
                 </a:solidFill>
@@ -6705,7 +6705,7 @@
         <p:spPr>
           <a:xfrm>
             <a:off x="9646919" y="1691640"/>
-            <a:ext cx="1828800" cy="530352"/>
+            <a:ext cx="1828800" cy="475488"/>
           </a:xfrm>
           <a:prstGeom prst="rect">
             <a:avLst/>
@@ -6747,23 +6747,23 @@
         </p:nvSpPr>
         <p:spPr>
           <a:xfrm>
-            <a:off x="9701784" y="1783080"/>
-            <a:ext cx="1737360" cy="365760"/>
-          </a:xfrm>
-          <a:prstGeom prst="rect">
-            <a:avLst/>
-          </a:prstGeom>
-          <a:noFill/>
-        </p:spPr>
-        <p:txBody>
-          <a:bodyPr wrap="square">
-            <a:spAutoFit/>
-          </a:bodyPr>
-          <a:lstStyle/>
-          <a:p>
-            <a:pPr algn="ctr"/>
-            <a:r>
-              <a:rPr sz="1200" b="0" i="0">
+            <a:off x="9701784" y="1764792"/>
+            <a:ext cx="1737360" cy="347472"/>
+          </a:xfrm>
+          <a:prstGeom prst="rect">
+            <a:avLst/>
+          </a:prstGeom>
+          <a:noFill/>
+        </p:spPr>
+        <p:txBody>
+          <a:bodyPr wrap="square">
+            <a:spAutoFit/>
+          </a:bodyPr>
+          <a:lstStyle/>
+          <a:p>
+            <a:pPr algn="ctr"/>
+            <a:r>
+              <a:rPr sz="1100" b="0" i="0">
                 <a:solidFill>
                   <a:srgbClr val="27AE60"/>
                 </a:solidFill>
@@ -6782,8 +6782,8 @@
         </p:nvSpPr>
         <p:spPr>
           <a:xfrm>
-            <a:off x="320040" y="2276856"/>
-            <a:ext cx="2926080" cy="530352"/>
+            <a:off x="320040" y="2221992"/>
+            <a:ext cx="2926080" cy="475488"/>
           </a:xfrm>
           <a:prstGeom prst="rect">
             <a:avLst/>
@@ -6825,23 +6825,23 @@
         </p:nvSpPr>
         <p:spPr>
           <a:xfrm>
-            <a:off x="374904" y="2368296"/>
-            <a:ext cx="2834640" cy="365760"/>
-          </a:xfrm>
-          <a:prstGeom prst="rect">
-            <a:avLst/>
-          </a:prstGeom>
-          <a:noFill/>
-        </p:spPr>
-        <p:txBody>
-          <a:bodyPr wrap="square">
-            <a:spAutoFit/>
-          </a:bodyPr>
-          <a:lstStyle/>
-          <a:p>
-            <a:pPr algn="ctr"/>
-            <a:r>
-              <a:rPr sz="1200" b="0" i="0">
+            <a:off x="374904" y="2295144"/>
+            <a:ext cx="2834640" cy="347472"/>
+          </a:xfrm>
+          <a:prstGeom prst="rect">
+            <a:avLst/>
+          </a:prstGeom>
+          <a:noFill/>
+        </p:spPr>
+        <p:txBody>
+          <a:bodyPr wrap="square">
+            <a:spAutoFit/>
+          </a:bodyPr>
+          <a:lstStyle/>
+          <a:p>
+            <a:pPr algn="ctr"/>
+            <a:r>
+              <a:rPr sz="1100" b="0" i="0">
                 <a:solidFill>
                   <a:srgbClr val="FFFFFF"/>
                 </a:solidFill>
@@ -6860,8 +6860,8 @@
         </p:nvSpPr>
         <p:spPr>
           <a:xfrm>
-            <a:off x="3337560" y="2276856"/>
-            <a:ext cx="2377440" cy="530352"/>
+            <a:off x="3337560" y="2221992"/>
+            <a:ext cx="2377440" cy="475488"/>
           </a:xfrm>
           <a:prstGeom prst="rect">
             <a:avLst/>
@@ -6903,23 +6903,23 @@
         </p:nvSpPr>
         <p:spPr>
           <a:xfrm>
-            <a:off x="3392424" y="2368296"/>
-            <a:ext cx="2286000" cy="365760"/>
-          </a:xfrm>
-          <a:prstGeom prst="rect">
-            <a:avLst/>
-          </a:prstGeom>
-          <a:noFill/>
-        </p:spPr>
-        <p:txBody>
-          <a:bodyPr wrap="square">
-            <a:spAutoFit/>
-          </a:bodyPr>
-          <a:lstStyle/>
-          <a:p>
-            <a:pPr algn="ctr"/>
-            <a:r>
-              <a:rPr sz="1200" b="0" i="0">
+            <a:off x="3392424" y="2295144"/>
+            <a:ext cx="2286000" cy="347472"/>
+          </a:xfrm>
+          <a:prstGeom prst="rect">
+            <a:avLst/>
+          </a:prstGeom>
+          <a:noFill/>
+        </p:spPr>
+        <p:txBody>
+          <a:bodyPr wrap="square">
+            <a:spAutoFit/>
+          </a:bodyPr>
+          <a:lstStyle/>
+          <a:p>
+            <a:pPr algn="ctr"/>
+            <a:r>
+              <a:rPr sz="1100" b="0" i="0">
                 <a:solidFill>
                   <a:srgbClr val="27AE60"/>
                 </a:solidFill>
@@ -6938,8 +6938,8 @@
         </p:nvSpPr>
         <p:spPr>
           <a:xfrm>
-            <a:off x="5806440" y="2276856"/>
-            <a:ext cx="1828800" cy="530352"/>
+            <a:off x="5806440" y="2221992"/>
+            <a:ext cx="1828800" cy="475488"/>
           </a:xfrm>
           <a:prstGeom prst="rect">
             <a:avLst/>
@@ -6981,23 +6981,23 @@
         </p:nvSpPr>
         <p:spPr>
           <a:xfrm>
-            <a:off x="5861303" y="2368296"/>
-            <a:ext cx="1737360" cy="365760"/>
-          </a:xfrm>
-          <a:prstGeom prst="rect">
-            <a:avLst/>
-          </a:prstGeom>
-          <a:noFill/>
-        </p:spPr>
-        <p:txBody>
-          <a:bodyPr wrap="square">
-            <a:spAutoFit/>
-          </a:bodyPr>
-          <a:lstStyle/>
-          <a:p>
-            <a:pPr algn="ctr"/>
-            <a:r>
-              <a:rPr sz="1200" b="0" i="0">
+            <a:off x="5861303" y="2295144"/>
+            <a:ext cx="1737360" cy="347472"/>
+          </a:xfrm>
+          <a:prstGeom prst="rect">
+            <a:avLst/>
+          </a:prstGeom>
+          <a:noFill/>
+        </p:spPr>
+        <p:txBody>
+          <a:bodyPr wrap="square">
+            <a:spAutoFit/>
+          </a:bodyPr>
+          <a:lstStyle/>
+          <a:p>
+            <a:pPr algn="ctr"/>
+            <a:r>
+              <a:rPr sz="1100" b="0" i="0">
                 <a:solidFill>
                   <a:srgbClr val="E74C3C"/>
                 </a:solidFill>
@@ -7016,8 +7016,8 @@
         </p:nvSpPr>
         <p:spPr>
           <a:xfrm>
-            <a:off x="7726679" y="2276856"/>
-            <a:ext cx="1828800" cy="530352"/>
+            <a:off x="7726679" y="2221992"/>
+            <a:ext cx="1828800" cy="475488"/>
           </a:xfrm>
           <a:prstGeom prst="rect">
             <a:avLst/>
@@ -7059,23 +7059,23 @@
         </p:nvSpPr>
         <p:spPr>
           <a:xfrm>
-            <a:off x="7781544" y="2368296"/>
-            <a:ext cx="1737360" cy="365760"/>
-          </a:xfrm>
-          <a:prstGeom prst="rect">
-            <a:avLst/>
-          </a:prstGeom>
-          <a:noFill/>
-        </p:spPr>
-        <p:txBody>
-          <a:bodyPr wrap="square">
-            <a:spAutoFit/>
-          </a:bodyPr>
-          <a:lstStyle/>
-          <a:p>
-            <a:pPr algn="ctr"/>
-            <a:r>
-              <a:rPr sz="1200" b="0" i="0">
+            <a:off x="7781544" y="2295144"/>
+            <a:ext cx="1737360" cy="347472"/>
+          </a:xfrm>
+          <a:prstGeom prst="rect">
+            <a:avLst/>
+          </a:prstGeom>
+          <a:noFill/>
+        </p:spPr>
+        <p:txBody>
+          <a:bodyPr wrap="square">
+            <a:spAutoFit/>
+          </a:bodyPr>
+          <a:lstStyle/>
+          <a:p>
+            <a:pPr algn="ctr"/>
+            <a:r>
+              <a:rPr sz="1100" b="0" i="0">
                 <a:solidFill>
                   <a:srgbClr val="E74C3C"/>
                 </a:solidFill>
@@ -7094,8 +7094,8 @@
         </p:nvSpPr>
         <p:spPr>
           <a:xfrm>
-            <a:off x="9646919" y="2276856"/>
-            <a:ext cx="1828800" cy="530352"/>
+            <a:off x="9646919" y="2221992"/>
+            <a:ext cx="1828800" cy="475488"/>
           </a:xfrm>
           <a:prstGeom prst="rect">
             <a:avLst/>
@@ -7137,23 +7137,23 @@
         </p:nvSpPr>
         <p:spPr>
           <a:xfrm>
-            <a:off x="9701784" y="2368296"/>
-            <a:ext cx="1737360" cy="365760"/>
-          </a:xfrm>
-          <a:prstGeom prst="rect">
-            <a:avLst/>
-          </a:prstGeom>
-          <a:noFill/>
-        </p:spPr>
-        <p:txBody>
-          <a:bodyPr wrap="square">
-            <a:spAutoFit/>
-          </a:bodyPr>
-          <a:lstStyle/>
-          <a:p>
-            <a:pPr algn="ctr"/>
-            <a:r>
-              <a:rPr sz="1200" b="0" i="0">
+            <a:off x="9701784" y="2295144"/>
+            <a:ext cx="1737360" cy="347472"/>
+          </a:xfrm>
+          <a:prstGeom prst="rect">
+            <a:avLst/>
+          </a:prstGeom>
+          <a:noFill/>
+        </p:spPr>
+        <p:txBody>
+          <a:bodyPr wrap="square">
+            <a:spAutoFit/>
+          </a:bodyPr>
+          <a:lstStyle/>
+          <a:p>
+            <a:pPr algn="ctr"/>
+            <a:r>
+              <a:rPr sz="1100" b="0" i="0">
                 <a:solidFill>
                   <a:srgbClr val="E74C3C"/>
                 </a:solidFill>
@@ -7172,8 +7172,8 @@
         </p:nvSpPr>
         <p:spPr>
           <a:xfrm>
-            <a:off x="320040" y="2862072"/>
-            <a:ext cx="2926080" cy="530352"/>
+            <a:off x="320040" y="2752344"/>
+            <a:ext cx="2926080" cy="475488"/>
           </a:xfrm>
           <a:prstGeom prst="rect">
             <a:avLst/>
@@ -7215,23 +7215,23 @@
         </p:nvSpPr>
         <p:spPr>
           <a:xfrm>
-            <a:off x="374904" y="2953512"/>
-            <a:ext cx="2834640" cy="365760"/>
-          </a:xfrm>
-          <a:prstGeom prst="rect">
-            <a:avLst/>
-          </a:prstGeom>
-          <a:noFill/>
-        </p:spPr>
-        <p:txBody>
-          <a:bodyPr wrap="square">
-            <a:spAutoFit/>
-          </a:bodyPr>
-          <a:lstStyle/>
-          <a:p>
-            <a:pPr algn="ctr"/>
-            <a:r>
-              <a:rPr sz="1200" b="0" i="0">
+            <a:off x="374904" y="2825496"/>
+            <a:ext cx="2834640" cy="347472"/>
+          </a:xfrm>
+          <a:prstGeom prst="rect">
+            <a:avLst/>
+          </a:prstGeom>
+          <a:noFill/>
+        </p:spPr>
+        <p:txBody>
+          <a:bodyPr wrap="square">
+            <a:spAutoFit/>
+          </a:bodyPr>
+          <a:lstStyle/>
+          <a:p>
+            <a:pPr algn="ctr"/>
+            <a:r>
+              <a:rPr sz="1100" b="0" i="0">
                 <a:solidFill>
                   <a:srgbClr val="FFFFFF"/>
                 </a:solidFill>
@@ -7250,8 +7250,8 @@
         </p:nvSpPr>
         <p:spPr>
           <a:xfrm>
-            <a:off x="3337560" y="2862072"/>
-            <a:ext cx="2377440" cy="530352"/>
+            <a:off x="3337560" y="2752344"/>
+            <a:ext cx="2377440" cy="475488"/>
           </a:xfrm>
           <a:prstGeom prst="rect">
             <a:avLst/>
@@ -7293,23 +7293,23 @@
         </p:nvSpPr>
         <p:spPr>
           <a:xfrm>
-            <a:off x="3392424" y="2953512"/>
-            <a:ext cx="2286000" cy="365760"/>
-          </a:xfrm>
-          <a:prstGeom prst="rect">
-            <a:avLst/>
-          </a:prstGeom>
-          <a:noFill/>
-        </p:spPr>
-        <p:txBody>
-          <a:bodyPr wrap="square">
-            <a:spAutoFit/>
-          </a:bodyPr>
-          <a:lstStyle/>
-          <a:p>
-            <a:pPr algn="ctr"/>
-            <a:r>
-              <a:rPr sz="1200" b="0" i="0">
+            <a:off x="3392424" y="2825496"/>
+            <a:ext cx="2286000" cy="347472"/>
+          </a:xfrm>
+          <a:prstGeom prst="rect">
+            <a:avLst/>
+          </a:prstGeom>
+          <a:noFill/>
+        </p:spPr>
+        <p:txBody>
+          <a:bodyPr wrap="square">
+            <a:spAutoFit/>
+          </a:bodyPr>
+          <a:lstStyle/>
+          <a:p>
+            <a:pPr algn="ctr"/>
+            <a:r>
+              <a:rPr sz="1100" b="0" i="0">
                 <a:solidFill>
                   <a:srgbClr val="27AE60"/>
                 </a:solidFill>
@@ -7328,8 +7328,8 @@
         </p:nvSpPr>
         <p:spPr>
           <a:xfrm>
-            <a:off x="5806440" y="2862072"/>
-            <a:ext cx="1828800" cy="530352"/>
+            <a:off x="5806440" y="2752344"/>
+            <a:ext cx="1828800" cy="475488"/>
           </a:xfrm>
           <a:prstGeom prst="rect">
             <a:avLst/>
@@ -7371,23 +7371,23 @@
         </p:nvSpPr>
         <p:spPr>
           <a:xfrm>
-            <a:off x="5861303" y="2953512"/>
-            <a:ext cx="1737360" cy="365760"/>
-          </a:xfrm>
-          <a:prstGeom prst="rect">
-            <a:avLst/>
-          </a:prstGeom>
-          <a:noFill/>
-        </p:spPr>
-        <p:txBody>
-          <a:bodyPr wrap="square">
-            <a:spAutoFit/>
-          </a:bodyPr>
-          <a:lstStyle/>
-          <a:p>
-            <a:pPr algn="ctr"/>
-            <a:r>
-              <a:rPr sz="1200" b="0" i="0">
+            <a:off x="5861303" y="2825496"/>
+            <a:ext cx="1737360" cy="347472"/>
+          </a:xfrm>
+          <a:prstGeom prst="rect">
+            <a:avLst/>
+          </a:prstGeom>
+          <a:noFill/>
+        </p:spPr>
+        <p:txBody>
+          <a:bodyPr wrap="square">
+            <a:spAutoFit/>
+          </a:bodyPr>
+          <a:lstStyle/>
+          <a:p>
+            <a:pPr algn="ctr"/>
+            <a:r>
+              <a:rPr sz="1100" b="0" i="0">
                 <a:solidFill>
                   <a:srgbClr val="E74C3C"/>
                 </a:solidFill>
@@ -7406,8 +7406,8 @@
         </p:nvSpPr>
         <p:spPr>
           <a:xfrm>
-            <a:off x="7726679" y="2862072"/>
-            <a:ext cx="1828800" cy="530352"/>
+            <a:off x="7726679" y="2752344"/>
+            <a:ext cx="1828800" cy="475488"/>
           </a:xfrm>
           <a:prstGeom prst="rect">
             <a:avLst/>
@@ -7449,23 +7449,23 @@
         </p:nvSpPr>
         <p:spPr>
           <a:xfrm>
-            <a:off x="7781544" y="2953512"/>
-            <a:ext cx="1737360" cy="365760"/>
-          </a:xfrm>
-          <a:prstGeom prst="rect">
-            <a:avLst/>
-          </a:prstGeom>
-          <a:noFill/>
-        </p:spPr>
-        <p:txBody>
-          <a:bodyPr wrap="square">
-            <a:spAutoFit/>
-          </a:bodyPr>
-          <a:lstStyle/>
-          <a:p>
-            <a:pPr algn="ctr"/>
-            <a:r>
-              <a:rPr sz="1200" b="0" i="0">
+            <a:off x="7781544" y="2825496"/>
+            <a:ext cx="1737360" cy="347472"/>
+          </a:xfrm>
+          <a:prstGeom prst="rect">
+            <a:avLst/>
+          </a:prstGeom>
+          <a:noFill/>
+        </p:spPr>
+        <p:txBody>
+          <a:bodyPr wrap="square">
+            <a:spAutoFit/>
+          </a:bodyPr>
+          <a:lstStyle/>
+          <a:p>
+            <a:pPr algn="ctr"/>
+            <a:r>
+              <a:rPr sz="1100" b="0" i="0">
                 <a:solidFill>
                   <a:srgbClr val="E74C3C"/>
                 </a:solidFill>
@@ -7484,8 +7484,8 @@
         </p:nvSpPr>
         <p:spPr>
           <a:xfrm>
-            <a:off x="9646919" y="2862072"/>
-            <a:ext cx="1828800" cy="530352"/>
+            <a:off x="9646919" y="2752344"/>
+            <a:ext cx="1828800" cy="475488"/>
           </a:xfrm>
           <a:prstGeom prst="rect">
             <a:avLst/>
@@ -7527,23 +7527,23 @@
         </p:nvSpPr>
         <p:spPr>
           <a:xfrm>
-            <a:off x="9701784" y="2953512"/>
-            <a:ext cx="1737360" cy="365760"/>
-          </a:xfrm>
-          <a:prstGeom prst="rect">
-            <a:avLst/>
-          </a:prstGeom>
-          <a:noFill/>
-        </p:spPr>
-        <p:txBody>
-          <a:bodyPr wrap="square">
-            <a:spAutoFit/>
-          </a:bodyPr>
-          <a:lstStyle/>
-          <a:p>
-            <a:pPr algn="ctr"/>
-            <a:r>
-              <a:rPr sz="1200" b="0" i="0">
+            <a:off x="9701784" y="2825496"/>
+            <a:ext cx="1737360" cy="347472"/>
+          </a:xfrm>
+          <a:prstGeom prst="rect">
+            <a:avLst/>
+          </a:prstGeom>
+          <a:noFill/>
+        </p:spPr>
+        <p:txBody>
+          <a:bodyPr wrap="square">
+            <a:spAutoFit/>
+          </a:bodyPr>
+          <a:lstStyle/>
+          <a:p>
+            <a:pPr algn="ctr"/>
+            <a:r>
+              <a:rPr sz="1100" b="0" i="0">
                 <a:solidFill>
                   <a:srgbClr val="E74C3C"/>
                 </a:solidFill>
@@ -7562,8 +7562,8 @@
         </p:nvSpPr>
         <p:spPr>
           <a:xfrm>
-            <a:off x="320040" y="3447288"/>
-            <a:ext cx="2926080" cy="530352"/>
+            <a:off x="320040" y="3282696"/>
+            <a:ext cx="2926080" cy="475488"/>
           </a:xfrm>
           <a:prstGeom prst="rect">
             <a:avLst/>
@@ -7605,23 +7605,23 @@
         </p:nvSpPr>
         <p:spPr>
           <a:xfrm>
-            <a:off x="374904" y="3538728"/>
-            <a:ext cx="2834640" cy="365760"/>
-          </a:xfrm>
-          <a:prstGeom prst="rect">
-            <a:avLst/>
-          </a:prstGeom>
-          <a:noFill/>
-        </p:spPr>
-        <p:txBody>
-          <a:bodyPr wrap="square">
-            <a:spAutoFit/>
-          </a:bodyPr>
-          <a:lstStyle/>
-          <a:p>
-            <a:pPr algn="ctr"/>
-            <a:r>
-              <a:rPr sz="1200" b="0" i="0">
+            <a:off x="374904" y="3355848"/>
+            <a:ext cx="2834640" cy="347472"/>
+          </a:xfrm>
+          <a:prstGeom prst="rect">
+            <a:avLst/>
+          </a:prstGeom>
+          <a:noFill/>
+        </p:spPr>
+        <p:txBody>
+          <a:bodyPr wrap="square">
+            <a:spAutoFit/>
+          </a:bodyPr>
+          <a:lstStyle/>
+          <a:p>
+            <a:pPr algn="ctr"/>
+            <a:r>
+              <a:rPr sz="1100" b="0" i="0">
                 <a:solidFill>
                   <a:srgbClr val="FFFFFF"/>
                 </a:solidFill>
@@ -7640,8 +7640,8 @@
         </p:nvSpPr>
         <p:spPr>
           <a:xfrm>
-            <a:off x="3337560" y="3447288"/>
-            <a:ext cx="2377440" cy="530352"/>
+            <a:off x="3337560" y="3282696"/>
+            <a:ext cx="2377440" cy="475488"/>
           </a:xfrm>
           <a:prstGeom prst="rect">
             <a:avLst/>
@@ -7683,23 +7683,23 @@
         </p:nvSpPr>
         <p:spPr>
           <a:xfrm>
-            <a:off x="3392424" y="3538728"/>
-            <a:ext cx="2286000" cy="365760"/>
-          </a:xfrm>
-          <a:prstGeom prst="rect">
-            <a:avLst/>
-          </a:prstGeom>
-          <a:noFill/>
-        </p:spPr>
-        <p:txBody>
-          <a:bodyPr wrap="square">
-            <a:spAutoFit/>
-          </a:bodyPr>
-          <a:lstStyle/>
-          <a:p>
-            <a:pPr algn="ctr"/>
-            <a:r>
-              <a:rPr sz="1200" b="0" i="0">
+            <a:off x="3392424" y="3355848"/>
+            <a:ext cx="2286000" cy="347472"/>
+          </a:xfrm>
+          <a:prstGeom prst="rect">
+            <a:avLst/>
+          </a:prstGeom>
+          <a:noFill/>
+        </p:spPr>
+        <p:txBody>
+          <a:bodyPr wrap="square">
+            <a:spAutoFit/>
+          </a:bodyPr>
+          <a:lstStyle/>
+          <a:p>
+            <a:pPr algn="ctr"/>
+            <a:r>
+              <a:rPr sz="1100" b="0" i="0">
                 <a:solidFill>
                   <a:srgbClr val="27AE60"/>
                 </a:solidFill>
@@ -7718,8 +7718,8 @@
         </p:nvSpPr>
         <p:spPr>
           <a:xfrm>
-            <a:off x="5806440" y="3447288"/>
-            <a:ext cx="1828800" cy="530352"/>
+            <a:off x="5806440" y="3282696"/>
+            <a:ext cx="1828800" cy="475488"/>
           </a:xfrm>
           <a:prstGeom prst="rect">
             <a:avLst/>
@@ -7761,23 +7761,23 @@
         </p:nvSpPr>
         <p:spPr>
           <a:xfrm>
-            <a:off x="5861303" y="3538728"/>
-            <a:ext cx="1737360" cy="365760"/>
-          </a:xfrm>
-          <a:prstGeom prst="rect">
-            <a:avLst/>
-          </a:prstGeom>
-          <a:noFill/>
-        </p:spPr>
-        <p:txBody>
-          <a:bodyPr wrap="square">
-            <a:spAutoFit/>
-          </a:bodyPr>
-          <a:lstStyle/>
-          <a:p>
-            <a:pPr algn="ctr"/>
-            <a:r>
-              <a:rPr sz="1200" b="0" i="0">
+            <a:off x="5861303" y="3355848"/>
+            <a:ext cx="1737360" cy="347472"/>
+          </a:xfrm>
+          <a:prstGeom prst="rect">
+            <a:avLst/>
+          </a:prstGeom>
+          <a:noFill/>
+        </p:spPr>
+        <p:txBody>
+          <a:bodyPr wrap="square">
+            <a:spAutoFit/>
+          </a:bodyPr>
+          <a:lstStyle/>
+          <a:p>
+            <a:pPr algn="ctr"/>
+            <a:r>
+              <a:rPr sz="1100" b="0" i="0">
                 <a:solidFill>
                   <a:srgbClr val="FFFFFF"/>
                 </a:solidFill>
@@ -7796,8 +7796,8 @@
         </p:nvSpPr>
         <p:spPr>
           <a:xfrm>
-            <a:off x="7726679" y="3447288"/>
-            <a:ext cx="1828800" cy="530352"/>
+            <a:off x="7726679" y="3282696"/>
+            <a:ext cx="1828800" cy="475488"/>
           </a:xfrm>
           <a:prstGeom prst="rect">
             <a:avLst/>
@@ -7839,23 +7839,23 @@
         </p:nvSpPr>
         <p:spPr>
           <a:xfrm>
-            <a:off x="7781544" y="3538728"/>
-            <a:ext cx="1737360" cy="365760"/>
-          </a:xfrm>
-          <a:prstGeom prst="rect">
-            <a:avLst/>
-          </a:prstGeom>
-          <a:noFill/>
-        </p:spPr>
-        <p:txBody>
-          <a:bodyPr wrap="square">
-            <a:spAutoFit/>
-          </a:bodyPr>
-          <a:lstStyle/>
-          <a:p>
-            <a:pPr algn="ctr"/>
-            <a:r>
-              <a:rPr sz="1200" b="0" i="0">
+            <a:off x="7781544" y="3355848"/>
+            <a:ext cx="1737360" cy="347472"/>
+          </a:xfrm>
+          <a:prstGeom prst="rect">
+            <a:avLst/>
+          </a:prstGeom>
+          <a:noFill/>
+        </p:spPr>
+        <p:txBody>
+          <a:bodyPr wrap="square">
+            <a:spAutoFit/>
+          </a:bodyPr>
+          <a:lstStyle/>
+          <a:p>
+            <a:pPr algn="ctr"/>
+            <a:r>
+              <a:rPr sz="1100" b="0" i="0">
                 <a:solidFill>
                   <a:srgbClr val="E74C3C"/>
                 </a:solidFill>
@@ -7874,8 +7874,8 @@
         </p:nvSpPr>
         <p:spPr>
           <a:xfrm>
-            <a:off x="9646919" y="3447288"/>
-            <a:ext cx="1828800" cy="530352"/>
+            <a:off x="9646919" y="3282696"/>
+            <a:ext cx="1828800" cy="475488"/>
           </a:xfrm>
           <a:prstGeom prst="rect">
             <a:avLst/>
@@ -7917,23 +7917,23 @@
         </p:nvSpPr>
         <p:spPr>
           <a:xfrm>
-            <a:off x="9701784" y="3538728"/>
-            <a:ext cx="1737360" cy="365760"/>
-          </a:xfrm>
-          <a:prstGeom prst="rect">
-            <a:avLst/>
-          </a:prstGeom>
-          <a:noFill/>
-        </p:spPr>
-        <p:txBody>
-          <a:bodyPr wrap="square">
-            <a:spAutoFit/>
-          </a:bodyPr>
-          <a:lstStyle/>
-          <a:p>
-            <a:pPr algn="ctr"/>
-            <a:r>
-              <a:rPr sz="1200" b="0" i="0">
+            <a:off x="9701784" y="3355848"/>
+            <a:ext cx="1737360" cy="347472"/>
+          </a:xfrm>
+          <a:prstGeom prst="rect">
+            <a:avLst/>
+          </a:prstGeom>
+          <a:noFill/>
+        </p:spPr>
+        <p:txBody>
+          <a:bodyPr wrap="square">
+            <a:spAutoFit/>
+          </a:bodyPr>
+          <a:lstStyle/>
+          <a:p>
+            <a:pPr algn="ctr"/>
+            <a:r>
+              <a:rPr sz="1100" b="0" i="0">
                 <a:solidFill>
                   <a:srgbClr val="E74C3C"/>
                 </a:solidFill>
@@ -7952,8 +7952,8 @@
         </p:nvSpPr>
         <p:spPr>
           <a:xfrm>
-            <a:off x="320040" y="4032504"/>
-            <a:ext cx="2926080" cy="530352"/>
+            <a:off x="320040" y="3813048"/>
+            <a:ext cx="2926080" cy="475488"/>
           </a:xfrm>
           <a:prstGeom prst="rect">
             <a:avLst/>
@@ -7995,23 +7995,23 @@
         </p:nvSpPr>
         <p:spPr>
           <a:xfrm>
-            <a:off x="374904" y="4123944"/>
-            <a:ext cx="2834640" cy="365760"/>
-          </a:xfrm>
-          <a:prstGeom prst="rect">
-            <a:avLst/>
-          </a:prstGeom>
-          <a:noFill/>
-        </p:spPr>
-        <p:txBody>
-          <a:bodyPr wrap="square">
-            <a:spAutoFit/>
-          </a:bodyPr>
-          <a:lstStyle/>
-          <a:p>
-            <a:pPr algn="ctr"/>
-            <a:r>
-              <a:rPr sz="1200" b="0" i="0">
+            <a:off x="374904" y="3886200"/>
+            <a:ext cx="2834640" cy="347472"/>
+          </a:xfrm>
+          <a:prstGeom prst="rect">
+            <a:avLst/>
+          </a:prstGeom>
+          <a:noFill/>
+        </p:spPr>
+        <p:txBody>
+          <a:bodyPr wrap="square">
+            <a:spAutoFit/>
+          </a:bodyPr>
+          <a:lstStyle/>
+          <a:p>
+            <a:pPr algn="ctr"/>
+            <a:r>
+              <a:rPr sz="1100" b="0" i="0">
                 <a:solidFill>
                   <a:srgbClr val="FFFFFF"/>
                 </a:solidFill>
@@ -8030,8 +8030,8 @@
         </p:nvSpPr>
         <p:spPr>
           <a:xfrm>
-            <a:off x="3337560" y="4032504"/>
-            <a:ext cx="2377440" cy="530352"/>
+            <a:off x="3337560" y="3813048"/>
+            <a:ext cx="2377440" cy="475488"/>
           </a:xfrm>
           <a:prstGeom prst="rect">
             <a:avLst/>
@@ -8073,23 +8073,23 @@
         </p:nvSpPr>
         <p:spPr>
           <a:xfrm>
-            <a:off x="3392424" y="4123944"/>
-            <a:ext cx="2286000" cy="365760"/>
-          </a:xfrm>
-          <a:prstGeom prst="rect">
-            <a:avLst/>
-          </a:prstGeom>
-          <a:noFill/>
-        </p:spPr>
-        <p:txBody>
-          <a:bodyPr wrap="square">
-            <a:spAutoFit/>
-          </a:bodyPr>
-          <a:lstStyle/>
-          <a:p>
-            <a:pPr algn="ctr"/>
-            <a:r>
-              <a:rPr sz="1200" b="0" i="0">
+            <a:off x="3392424" y="3886200"/>
+            <a:ext cx="2286000" cy="347472"/>
+          </a:xfrm>
+          <a:prstGeom prst="rect">
+            <a:avLst/>
+          </a:prstGeom>
+          <a:noFill/>
+        </p:spPr>
+        <p:txBody>
+          <a:bodyPr wrap="square">
+            <a:spAutoFit/>
+          </a:bodyPr>
+          <a:lstStyle/>
+          <a:p>
+            <a:pPr algn="ctr"/>
+            <a:r>
+              <a:rPr sz="1100" b="0" i="0">
                 <a:solidFill>
                   <a:srgbClr val="27AE60"/>
                 </a:solidFill>
@@ -8108,8 +8108,8 @@
         </p:nvSpPr>
         <p:spPr>
           <a:xfrm>
-            <a:off x="5806440" y="4032504"/>
-            <a:ext cx="1828800" cy="530352"/>
+            <a:off x="5806440" y="3813048"/>
+            <a:ext cx="1828800" cy="475488"/>
           </a:xfrm>
           <a:prstGeom prst="rect">
             <a:avLst/>
@@ -8151,23 +8151,23 @@
         </p:nvSpPr>
         <p:spPr>
           <a:xfrm>
-            <a:off x="5861303" y="4123944"/>
-            <a:ext cx="1737360" cy="365760"/>
-          </a:xfrm>
-          <a:prstGeom prst="rect">
-            <a:avLst/>
-          </a:prstGeom>
-          <a:noFill/>
-        </p:spPr>
-        <p:txBody>
-          <a:bodyPr wrap="square">
-            <a:spAutoFit/>
-          </a:bodyPr>
-          <a:lstStyle/>
-          <a:p>
-            <a:pPr algn="ctr"/>
-            <a:r>
-              <a:rPr sz="1200" b="0" i="0">
+            <a:off x="5861303" y="3886200"/>
+            <a:ext cx="1737360" cy="347472"/>
+          </a:xfrm>
+          <a:prstGeom prst="rect">
+            <a:avLst/>
+          </a:prstGeom>
+          <a:noFill/>
+        </p:spPr>
+        <p:txBody>
+          <a:bodyPr wrap="square">
+            <a:spAutoFit/>
+          </a:bodyPr>
+          <a:lstStyle/>
+          <a:p>
+            <a:pPr algn="ctr"/>
+            <a:r>
+              <a:rPr sz="1100" b="0" i="0">
                 <a:solidFill>
                   <a:srgbClr val="FFFFFF"/>
                 </a:solidFill>
@@ -8186,8 +8186,8 @@
         </p:nvSpPr>
         <p:spPr>
           <a:xfrm>
-            <a:off x="7726679" y="4032504"/>
-            <a:ext cx="1828800" cy="530352"/>
+            <a:off x="7726679" y="3813048"/>
+            <a:ext cx="1828800" cy="475488"/>
           </a:xfrm>
           <a:prstGeom prst="rect">
             <a:avLst/>
@@ -8229,23 +8229,23 @@
         </p:nvSpPr>
         <p:spPr>
           <a:xfrm>
-            <a:off x="7781544" y="4123944"/>
-            <a:ext cx="1737360" cy="365760"/>
-          </a:xfrm>
-          <a:prstGeom prst="rect">
-            <a:avLst/>
-          </a:prstGeom>
-          <a:noFill/>
-        </p:spPr>
-        <p:txBody>
-          <a:bodyPr wrap="square">
-            <a:spAutoFit/>
-          </a:bodyPr>
-          <a:lstStyle/>
-          <a:p>
-            <a:pPr algn="ctr"/>
-            <a:r>
-              <a:rPr sz="1200" b="0" i="0">
+            <a:off x="7781544" y="3886200"/>
+            <a:ext cx="1737360" cy="347472"/>
+          </a:xfrm>
+          <a:prstGeom prst="rect">
+            <a:avLst/>
+          </a:prstGeom>
+          <a:noFill/>
+        </p:spPr>
+        <p:txBody>
+          <a:bodyPr wrap="square">
+            <a:spAutoFit/>
+          </a:bodyPr>
+          <a:lstStyle/>
+          <a:p>
+            <a:pPr algn="ctr"/>
+            <a:r>
+              <a:rPr sz="1100" b="0" i="0">
                 <a:solidFill>
                   <a:srgbClr val="FFFFFF"/>
                 </a:solidFill>
@@ -8264,8 +8264,8 @@
         </p:nvSpPr>
         <p:spPr>
           <a:xfrm>
-            <a:off x="9646919" y="4032504"/>
-            <a:ext cx="1828800" cy="530352"/>
+            <a:off x="9646919" y="3813048"/>
+            <a:ext cx="1828800" cy="475488"/>
           </a:xfrm>
           <a:prstGeom prst="rect">
             <a:avLst/>
@@ -8307,23 +8307,23 @@
         </p:nvSpPr>
         <p:spPr>
           <a:xfrm>
-            <a:off x="9701784" y="4123944"/>
-            <a:ext cx="1737360" cy="365760"/>
-          </a:xfrm>
-          <a:prstGeom prst="rect">
-            <a:avLst/>
-          </a:prstGeom>
-          <a:noFill/>
-        </p:spPr>
-        <p:txBody>
-          <a:bodyPr wrap="square">
-            <a:spAutoFit/>
-          </a:bodyPr>
-          <a:lstStyle/>
-          <a:p>
-            <a:pPr algn="ctr"/>
-            <a:r>
-              <a:rPr sz="1200" b="0" i="0">
+            <a:off x="9701784" y="3886200"/>
+            <a:ext cx="1737360" cy="347472"/>
+          </a:xfrm>
+          <a:prstGeom prst="rect">
+            <a:avLst/>
+          </a:prstGeom>
+          <a:noFill/>
+        </p:spPr>
+        <p:txBody>
+          <a:bodyPr wrap="square">
+            <a:spAutoFit/>
+          </a:bodyPr>
+          <a:lstStyle/>
+          <a:p>
+            <a:pPr algn="ctr"/>
+            <a:r>
+              <a:rPr sz="1100" b="0" i="0">
                 <a:solidFill>
                   <a:srgbClr val="E74C3C"/>
                 </a:solidFill>
@@ -8342,8 +8342,8 @@
         </p:nvSpPr>
         <p:spPr>
           <a:xfrm>
-            <a:off x="320040" y="4617720"/>
-            <a:ext cx="2926080" cy="530352"/>
+            <a:off x="320040" y="4343400"/>
+            <a:ext cx="2926080" cy="475488"/>
           </a:xfrm>
           <a:prstGeom prst="rect">
             <a:avLst/>
@@ -8385,23 +8385,23 @@
         </p:nvSpPr>
         <p:spPr>
           <a:xfrm>
-            <a:off x="374904" y="4709160"/>
-            <a:ext cx="2834640" cy="365760"/>
-          </a:xfrm>
-          <a:prstGeom prst="rect">
-            <a:avLst/>
-          </a:prstGeom>
-          <a:noFill/>
-        </p:spPr>
-        <p:txBody>
-          <a:bodyPr wrap="square">
-            <a:spAutoFit/>
-          </a:bodyPr>
-          <a:lstStyle/>
-          <a:p>
-            <a:pPr algn="ctr"/>
-            <a:r>
-              <a:rPr sz="1200" b="0" i="0">
+            <a:off x="374904" y="4416552"/>
+            <a:ext cx="2834640" cy="347472"/>
+          </a:xfrm>
+          <a:prstGeom prst="rect">
+            <a:avLst/>
+          </a:prstGeom>
+          <a:noFill/>
+        </p:spPr>
+        <p:txBody>
+          <a:bodyPr wrap="square">
+            <a:spAutoFit/>
+          </a:bodyPr>
+          <a:lstStyle/>
+          <a:p>
+            <a:pPr algn="ctr"/>
+            <a:r>
+              <a:rPr sz="1100" b="0" i="0">
                 <a:solidFill>
                   <a:srgbClr val="FFFFFF"/>
                 </a:solidFill>
@@ -8420,8 +8420,8 @@
         </p:nvSpPr>
         <p:spPr>
           <a:xfrm>
-            <a:off x="3337560" y="4617720"/>
-            <a:ext cx="2377440" cy="530352"/>
+            <a:off x="3337560" y="4343400"/>
+            <a:ext cx="2377440" cy="475488"/>
           </a:xfrm>
           <a:prstGeom prst="rect">
             <a:avLst/>
@@ -8463,23 +8463,23 @@
         </p:nvSpPr>
         <p:spPr>
           <a:xfrm>
-            <a:off x="3392424" y="4709160"/>
-            <a:ext cx="2286000" cy="365760"/>
-          </a:xfrm>
-          <a:prstGeom prst="rect">
-            <a:avLst/>
-          </a:prstGeom>
-          <a:noFill/>
-        </p:spPr>
-        <p:txBody>
-          <a:bodyPr wrap="square">
-            <a:spAutoFit/>
-          </a:bodyPr>
-          <a:lstStyle/>
-          <a:p>
-            <a:pPr algn="ctr"/>
-            <a:r>
-              <a:rPr sz="1200" b="0" i="0">
+            <a:off x="3392424" y="4416552"/>
+            <a:ext cx="2286000" cy="347472"/>
+          </a:xfrm>
+          <a:prstGeom prst="rect">
+            <a:avLst/>
+          </a:prstGeom>
+          <a:noFill/>
+        </p:spPr>
+        <p:txBody>
+          <a:bodyPr wrap="square">
+            <a:spAutoFit/>
+          </a:bodyPr>
+          <a:lstStyle/>
+          <a:p>
+            <a:pPr algn="ctr"/>
+            <a:r>
+              <a:rPr sz="1100" b="0" i="0">
                 <a:solidFill>
                   <a:srgbClr val="27AE60"/>
                 </a:solidFill>
@@ -8498,8 +8498,8 @@
         </p:nvSpPr>
         <p:spPr>
           <a:xfrm>
-            <a:off x="5806440" y="4617720"/>
-            <a:ext cx="1828800" cy="530352"/>
+            <a:off x="5806440" y="4343400"/>
+            <a:ext cx="1828800" cy="475488"/>
           </a:xfrm>
           <a:prstGeom prst="rect">
             <a:avLst/>
@@ -8541,23 +8541,23 @@
         </p:nvSpPr>
         <p:spPr>
           <a:xfrm>
-            <a:off x="5861303" y="4709160"/>
-            <a:ext cx="1737360" cy="365760"/>
-          </a:xfrm>
-          <a:prstGeom prst="rect">
-            <a:avLst/>
-          </a:prstGeom>
-          <a:noFill/>
-        </p:spPr>
-        <p:txBody>
-          <a:bodyPr wrap="square">
-            <a:spAutoFit/>
-          </a:bodyPr>
-          <a:lstStyle/>
-          <a:p>
-            <a:pPr algn="ctr"/>
-            <a:r>
-              <a:rPr sz="1200" b="0" i="0">
+            <a:off x="5861303" y="4416552"/>
+            <a:ext cx="1737360" cy="347472"/>
+          </a:xfrm>
+          <a:prstGeom prst="rect">
+            <a:avLst/>
+          </a:prstGeom>
+          <a:noFill/>
+        </p:spPr>
+        <p:txBody>
+          <a:bodyPr wrap="square">
+            <a:spAutoFit/>
+          </a:bodyPr>
+          <a:lstStyle/>
+          <a:p>
+            <a:pPr algn="ctr"/>
+            <a:r>
+              <a:rPr sz="1100" b="0" i="0">
                 <a:solidFill>
                   <a:srgbClr val="FFFFFF"/>
                 </a:solidFill>
@@ -8576,8 +8576,8 @@
         </p:nvSpPr>
         <p:spPr>
           <a:xfrm>
-            <a:off x="7726679" y="4617720"/>
-            <a:ext cx="1828800" cy="530352"/>
+            <a:off x="7726679" y="4343400"/>
+            <a:ext cx="1828800" cy="475488"/>
           </a:xfrm>
           <a:prstGeom prst="rect">
             <a:avLst/>
@@ -8619,23 +8619,23 @@
         </p:nvSpPr>
         <p:spPr>
           <a:xfrm>
-            <a:off x="7781544" y="4709160"/>
-            <a:ext cx="1737360" cy="365760"/>
-          </a:xfrm>
-          <a:prstGeom prst="rect">
-            <a:avLst/>
-          </a:prstGeom>
-          <a:noFill/>
-        </p:spPr>
-        <p:txBody>
-          <a:bodyPr wrap="square">
-            <a:spAutoFit/>
-          </a:bodyPr>
-          <a:lstStyle/>
-          <a:p>
-            <a:pPr algn="ctr"/>
-            <a:r>
-              <a:rPr sz="1200" b="0" i="0">
+            <a:off x="7781544" y="4416552"/>
+            <a:ext cx="1737360" cy="347472"/>
+          </a:xfrm>
+          <a:prstGeom prst="rect">
+            <a:avLst/>
+          </a:prstGeom>
+          <a:noFill/>
+        </p:spPr>
+        <p:txBody>
+          <a:bodyPr wrap="square">
+            <a:spAutoFit/>
+          </a:bodyPr>
+          <a:lstStyle/>
+          <a:p>
+            <a:pPr algn="ctr"/>
+            <a:r>
+              <a:rPr sz="1100" b="0" i="0">
                 <a:solidFill>
                   <a:srgbClr val="E74C3C"/>
                 </a:solidFill>
@@ -8654,8 +8654,8 @@
         </p:nvSpPr>
         <p:spPr>
           <a:xfrm>
-            <a:off x="9646919" y="4617720"/>
-            <a:ext cx="1828800" cy="530352"/>
+            <a:off x="9646919" y="4343400"/>
+            <a:ext cx="1828800" cy="475488"/>
           </a:xfrm>
           <a:prstGeom prst="rect">
             <a:avLst/>
@@ -8697,23 +8697,23 @@
         </p:nvSpPr>
         <p:spPr>
           <a:xfrm>
-            <a:off x="9701784" y="4709160"/>
-            <a:ext cx="1737360" cy="365760"/>
-          </a:xfrm>
-          <a:prstGeom prst="rect">
-            <a:avLst/>
-          </a:prstGeom>
-          <a:noFill/>
-        </p:spPr>
-        <p:txBody>
-          <a:bodyPr wrap="square">
-            <a:spAutoFit/>
-          </a:bodyPr>
-          <a:lstStyle/>
-          <a:p>
-            <a:pPr algn="ctr"/>
-            <a:r>
-              <a:rPr sz="1200" b="0" i="0">
+            <a:off x="9701784" y="4416552"/>
+            <a:ext cx="1737360" cy="347472"/>
+          </a:xfrm>
+          <a:prstGeom prst="rect">
+            <a:avLst/>
+          </a:prstGeom>
+          <a:noFill/>
+        </p:spPr>
+        <p:txBody>
+          <a:bodyPr wrap="square">
+            <a:spAutoFit/>
+          </a:bodyPr>
+          <a:lstStyle/>
+          <a:p>
+            <a:pPr algn="ctr"/>
+            <a:r>
+              <a:rPr sz="1100" b="0" i="0">
                 <a:solidFill>
                   <a:srgbClr val="E74C3C"/>
                 </a:solidFill>
@@ -8732,8 +8732,8 @@
         </p:nvSpPr>
         <p:spPr>
           <a:xfrm>
-            <a:off x="320040" y="5202936"/>
-            <a:ext cx="2926080" cy="530352"/>
+            <a:off x="320040" y="4873752"/>
+            <a:ext cx="2926080" cy="475488"/>
           </a:xfrm>
           <a:prstGeom prst="rect">
             <a:avLst/>
@@ -8775,23 +8775,23 @@
         </p:nvSpPr>
         <p:spPr>
           <a:xfrm>
-            <a:off x="374904" y="5294375"/>
-            <a:ext cx="2834640" cy="365760"/>
-          </a:xfrm>
-          <a:prstGeom prst="rect">
-            <a:avLst/>
-          </a:prstGeom>
-          <a:noFill/>
-        </p:spPr>
-        <p:txBody>
-          <a:bodyPr wrap="square">
-            <a:spAutoFit/>
-          </a:bodyPr>
-          <a:lstStyle/>
-          <a:p>
-            <a:pPr algn="ctr"/>
-            <a:r>
-              <a:rPr sz="1200" b="0" i="0">
+            <a:off x="374904" y="4946904"/>
+            <a:ext cx="2834640" cy="347472"/>
+          </a:xfrm>
+          <a:prstGeom prst="rect">
+            <a:avLst/>
+          </a:prstGeom>
+          <a:noFill/>
+        </p:spPr>
+        <p:txBody>
+          <a:bodyPr wrap="square">
+            <a:spAutoFit/>
+          </a:bodyPr>
+          <a:lstStyle/>
+          <a:p>
+            <a:pPr algn="ctr"/>
+            <a:r>
+              <a:rPr sz="1100" b="0" i="0">
                 <a:solidFill>
                   <a:srgbClr val="FFFFFF"/>
                 </a:solidFill>
@@ -8810,8 +8810,8 @@
         </p:nvSpPr>
         <p:spPr>
           <a:xfrm>
-            <a:off x="3337560" y="5202936"/>
-            <a:ext cx="2377440" cy="530352"/>
+            <a:off x="3337560" y="4873752"/>
+            <a:ext cx="2377440" cy="475488"/>
           </a:xfrm>
           <a:prstGeom prst="rect">
             <a:avLst/>
@@ -8853,29 +8853,29 @@
         </p:nvSpPr>
         <p:spPr>
           <a:xfrm>
-            <a:off x="3392424" y="5294375"/>
-            <a:ext cx="2286000" cy="365760"/>
-          </a:xfrm>
-          <a:prstGeom prst="rect">
-            <a:avLst/>
-          </a:prstGeom>
-          <a:noFill/>
-        </p:spPr>
-        <p:txBody>
-          <a:bodyPr wrap="square">
-            <a:spAutoFit/>
-          </a:bodyPr>
-          <a:lstStyle/>
-          <a:p>
-            <a:pPr algn="ctr"/>
-            <a:r>
-              <a:rPr sz="1200" b="0" i="0">
+            <a:off x="3392424" y="4946904"/>
+            <a:ext cx="2286000" cy="347472"/>
+          </a:xfrm>
+          <a:prstGeom prst="rect">
+            <a:avLst/>
+          </a:prstGeom>
+          <a:noFill/>
+        </p:spPr>
+        <p:txBody>
+          <a:bodyPr wrap="square">
+            <a:spAutoFit/>
+          </a:bodyPr>
+          <a:lstStyle/>
+          <a:p>
+            <a:pPr algn="ctr"/>
+            <a:r>
+              <a:rPr sz="1100" b="0" i="0">
                 <a:solidFill>
                   <a:srgbClr val="27AE60"/>
                 </a:solidFill>
                 <a:latin typeface="Calibri"/>
               </a:rPr>
-              <a:t>✅ FREE</a:t>
+              <a:t>✅ FREE / ₹0</a:t>
             </a:r>
           </a:p>
         </p:txBody>
@@ -8888,8 +8888,8 @@
         </p:nvSpPr>
         <p:spPr>
           <a:xfrm>
-            <a:off x="5806440" y="5202936"/>
-            <a:ext cx="1828800" cy="530352"/>
+            <a:off x="5806440" y="4873752"/>
+            <a:ext cx="1828800" cy="475488"/>
           </a:xfrm>
           <a:prstGeom prst="rect">
             <a:avLst/>
@@ -8931,23 +8931,23 @@
         </p:nvSpPr>
         <p:spPr>
           <a:xfrm>
-            <a:off x="5861303" y="5294375"/>
-            <a:ext cx="1737360" cy="365760"/>
-          </a:xfrm>
-          <a:prstGeom prst="rect">
-            <a:avLst/>
-          </a:prstGeom>
-          <a:noFill/>
-        </p:spPr>
-        <p:txBody>
-          <a:bodyPr wrap="square">
-            <a:spAutoFit/>
-          </a:bodyPr>
-          <a:lstStyle/>
-          <a:p>
-            <a:pPr algn="ctr"/>
-            <a:r>
-              <a:rPr sz="1200" b="0" i="0">
+            <a:off x="5861303" y="4946904"/>
+            <a:ext cx="1737360" cy="347472"/>
+          </a:xfrm>
+          <a:prstGeom prst="rect">
+            <a:avLst/>
+          </a:prstGeom>
+          <a:noFill/>
+        </p:spPr>
+        <p:txBody>
+          <a:bodyPr wrap="square">
+            <a:spAutoFit/>
+          </a:bodyPr>
+          <a:lstStyle/>
+          <a:p>
+            <a:pPr algn="ctr"/>
+            <a:r>
+              <a:rPr sz="1100" b="0" i="0">
                 <a:solidFill>
                   <a:srgbClr val="F39C12"/>
                 </a:solidFill>
@@ -8966,8 +8966,8 @@
         </p:nvSpPr>
         <p:spPr>
           <a:xfrm>
-            <a:off x="7726679" y="5202936"/>
-            <a:ext cx="1828800" cy="530352"/>
+            <a:off x="7726679" y="4873752"/>
+            <a:ext cx="1828800" cy="475488"/>
           </a:xfrm>
           <a:prstGeom prst="rect">
             <a:avLst/>
@@ -9009,23 +9009,23 @@
         </p:nvSpPr>
         <p:spPr>
           <a:xfrm>
-            <a:off x="7781544" y="5294375"/>
-            <a:ext cx="1737360" cy="365760"/>
-          </a:xfrm>
-          <a:prstGeom prst="rect">
-            <a:avLst/>
-          </a:prstGeom>
-          <a:noFill/>
-        </p:spPr>
-        <p:txBody>
-          <a:bodyPr wrap="square">
-            <a:spAutoFit/>
-          </a:bodyPr>
-          <a:lstStyle/>
-          <a:p>
-            <a:pPr algn="ctr"/>
-            <a:r>
-              <a:rPr sz="1200" b="0" i="0">
+            <a:off x="7781544" y="4946904"/>
+            <a:ext cx="1737360" cy="347472"/>
+          </a:xfrm>
+          <a:prstGeom prst="rect">
+            <a:avLst/>
+          </a:prstGeom>
+          <a:noFill/>
+        </p:spPr>
+        <p:txBody>
+          <a:bodyPr wrap="square">
+            <a:spAutoFit/>
+          </a:bodyPr>
+          <a:lstStyle/>
+          <a:p>
+            <a:pPr algn="ctr"/>
+            <a:r>
+              <a:rPr sz="1100" b="0" i="0">
                 <a:solidFill>
                   <a:srgbClr val="F39C12"/>
                 </a:solidFill>
@@ -9044,8 +9044,8 @@
         </p:nvSpPr>
         <p:spPr>
           <a:xfrm>
-            <a:off x="9646919" y="5202936"/>
-            <a:ext cx="1828800" cy="530352"/>
+            <a:off x="9646919" y="4873752"/>
+            <a:ext cx="1828800" cy="475488"/>
           </a:xfrm>
           <a:prstGeom prst="rect">
             <a:avLst/>
@@ -9087,23 +9087,23 @@
         </p:nvSpPr>
         <p:spPr>
           <a:xfrm>
-            <a:off x="9701784" y="5294375"/>
-            <a:ext cx="1737360" cy="365760"/>
-          </a:xfrm>
-          <a:prstGeom prst="rect">
-            <a:avLst/>
-          </a:prstGeom>
-          <a:noFill/>
-        </p:spPr>
-        <p:txBody>
-          <a:bodyPr wrap="square">
-            <a:spAutoFit/>
-          </a:bodyPr>
-          <a:lstStyle/>
-          <a:p>
-            <a:pPr algn="ctr"/>
-            <a:r>
-              <a:rPr sz="1200" b="0" i="0">
+            <a:off x="9701784" y="4946904"/>
+            <a:ext cx="1737360" cy="347472"/>
+          </a:xfrm>
+          <a:prstGeom prst="rect">
+            <a:avLst/>
+          </a:prstGeom>
+          <a:noFill/>
+        </p:spPr>
+        <p:txBody>
+          <a:bodyPr wrap="square">
+            <a:spAutoFit/>
+          </a:bodyPr>
+          <a:lstStyle/>
+          <a:p>
+            <a:pPr algn="ctr"/>
+            <a:r>
+              <a:rPr sz="1100" b="0" i="0">
                 <a:solidFill>
                   <a:srgbClr val="F39C12"/>
                 </a:solidFill>
@@ -9122,8 +9122,8 @@
         </p:nvSpPr>
         <p:spPr>
           <a:xfrm>
-            <a:off x="320040" y="5788152"/>
-            <a:ext cx="2926080" cy="530352"/>
+            <a:off x="320040" y="5404104"/>
+            <a:ext cx="2926080" cy="475488"/>
           </a:xfrm>
           <a:prstGeom prst="rect">
             <a:avLst/>
@@ -9165,23 +9165,23 @@
         </p:nvSpPr>
         <p:spPr>
           <a:xfrm>
-            <a:off x="374904" y="5879592"/>
-            <a:ext cx="2834640" cy="365760"/>
-          </a:xfrm>
-          <a:prstGeom prst="rect">
-            <a:avLst/>
-          </a:prstGeom>
-          <a:noFill/>
-        </p:spPr>
-        <p:txBody>
-          <a:bodyPr wrap="square">
-            <a:spAutoFit/>
-          </a:bodyPr>
-          <a:lstStyle/>
-          <a:p>
-            <a:pPr algn="ctr"/>
-            <a:r>
-              <a:rPr sz="1200" b="0" i="0">
+            <a:off x="374904" y="5477256"/>
+            <a:ext cx="2834640" cy="347472"/>
+          </a:xfrm>
+          <a:prstGeom prst="rect">
+            <a:avLst/>
+          </a:prstGeom>
+          <a:noFill/>
+        </p:spPr>
+        <p:txBody>
+          <a:bodyPr wrap="square">
+            <a:spAutoFit/>
+          </a:bodyPr>
+          <a:lstStyle/>
+          <a:p>
+            <a:pPr algn="ctr"/>
+            <a:r>
+              <a:rPr sz="1100" b="0" i="0">
                 <a:solidFill>
                   <a:srgbClr val="FFFFFF"/>
                 </a:solidFill>
@@ -9200,8 +9200,8 @@
         </p:nvSpPr>
         <p:spPr>
           <a:xfrm>
-            <a:off x="3337560" y="5788152"/>
-            <a:ext cx="2377440" cy="530352"/>
+            <a:off x="3337560" y="5404104"/>
+            <a:ext cx="2377440" cy="475488"/>
           </a:xfrm>
           <a:prstGeom prst="rect">
             <a:avLst/>
@@ -9243,23 +9243,23 @@
         </p:nvSpPr>
         <p:spPr>
           <a:xfrm>
-            <a:off x="3392424" y="5879592"/>
-            <a:ext cx="2286000" cy="365760"/>
-          </a:xfrm>
-          <a:prstGeom prst="rect">
-            <a:avLst/>
-          </a:prstGeom>
-          <a:noFill/>
-        </p:spPr>
-        <p:txBody>
-          <a:bodyPr wrap="square">
-            <a:spAutoFit/>
-          </a:bodyPr>
-          <a:lstStyle/>
-          <a:p>
-            <a:pPr algn="ctr"/>
-            <a:r>
-              <a:rPr sz="1200" b="0" i="0">
+            <a:off x="3392424" y="5477256"/>
+            <a:ext cx="2286000" cy="347472"/>
+          </a:xfrm>
+          <a:prstGeom prst="rect">
+            <a:avLst/>
+          </a:prstGeom>
+          <a:noFill/>
+        </p:spPr>
+        <p:txBody>
+          <a:bodyPr wrap="square">
+            <a:spAutoFit/>
+          </a:bodyPr>
+          <a:lstStyle/>
+          <a:p>
+            <a:pPr algn="ctr"/>
+            <a:r>
+              <a:rPr sz="1100" b="0" i="0">
                 <a:solidFill>
                   <a:srgbClr val="27AE60"/>
                 </a:solidFill>
@@ -9278,8 +9278,8 @@
         </p:nvSpPr>
         <p:spPr>
           <a:xfrm>
-            <a:off x="5806440" y="5788152"/>
-            <a:ext cx="1828800" cy="530352"/>
+            <a:off x="5806440" y="5404104"/>
+            <a:ext cx="1828800" cy="475488"/>
           </a:xfrm>
           <a:prstGeom prst="rect">
             <a:avLst/>
@@ -9321,23 +9321,23 @@
         </p:nvSpPr>
         <p:spPr>
           <a:xfrm>
-            <a:off x="5861303" y="5879592"/>
-            <a:ext cx="1737360" cy="365760"/>
-          </a:xfrm>
-          <a:prstGeom prst="rect">
-            <a:avLst/>
-          </a:prstGeom>
-          <a:noFill/>
-        </p:spPr>
-        <p:txBody>
-          <a:bodyPr wrap="square">
-            <a:spAutoFit/>
-          </a:bodyPr>
-          <a:lstStyle/>
-          <a:p>
-            <a:pPr algn="ctr"/>
-            <a:r>
-              <a:rPr sz="1200" b="0" i="0">
+            <a:off x="5861303" y="5477256"/>
+            <a:ext cx="1737360" cy="347472"/>
+          </a:xfrm>
+          <a:prstGeom prst="rect">
+            <a:avLst/>
+          </a:prstGeom>
+          <a:noFill/>
+        </p:spPr>
+        <p:txBody>
+          <a:bodyPr wrap="square">
+            <a:spAutoFit/>
+          </a:bodyPr>
+          <a:lstStyle/>
+          <a:p>
+            <a:pPr algn="ctr"/>
+            <a:r>
+              <a:rPr sz="1100" b="0" i="0">
                 <a:solidFill>
                   <a:srgbClr val="E74C3C"/>
                 </a:solidFill>
@@ -9356,8 +9356,8 @@
         </p:nvSpPr>
         <p:spPr>
           <a:xfrm>
-            <a:off x="7726679" y="5788152"/>
-            <a:ext cx="1828800" cy="530352"/>
+            <a:off x="7726679" y="5404104"/>
+            <a:ext cx="1828800" cy="475488"/>
           </a:xfrm>
           <a:prstGeom prst="rect">
             <a:avLst/>
@@ -9399,23 +9399,23 @@
         </p:nvSpPr>
         <p:spPr>
           <a:xfrm>
-            <a:off x="7781544" y="5879592"/>
-            <a:ext cx="1737360" cy="365760"/>
-          </a:xfrm>
-          <a:prstGeom prst="rect">
-            <a:avLst/>
-          </a:prstGeom>
-          <a:noFill/>
-        </p:spPr>
-        <p:txBody>
-          <a:bodyPr wrap="square">
-            <a:spAutoFit/>
-          </a:bodyPr>
-          <a:lstStyle/>
-          <a:p>
-            <a:pPr algn="ctr"/>
-            <a:r>
-              <a:rPr sz="1200" b="0" i="0">
+            <a:off x="7781544" y="5477256"/>
+            <a:ext cx="1737360" cy="347472"/>
+          </a:xfrm>
+          <a:prstGeom prst="rect">
+            <a:avLst/>
+          </a:prstGeom>
+          <a:noFill/>
+        </p:spPr>
+        <p:txBody>
+          <a:bodyPr wrap="square">
+            <a:spAutoFit/>
+          </a:bodyPr>
+          <a:lstStyle/>
+          <a:p>
+            <a:pPr algn="ctr"/>
+            <a:r>
+              <a:rPr sz="1100" b="0" i="0">
                 <a:solidFill>
                   <a:srgbClr val="E74C3C"/>
                 </a:solidFill>
@@ -9434,8 +9434,8 @@
         </p:nvSpPr>
         <p:spPr>
           <a:xfrm>
-            <a:off x="9646919" y="5788152"/>
-            <a:ext cx="1828800" cy="530352"/>
+            <a:off x="9646919" y="5404104"/>
+            <a:ext cx="1828800" cy="475488"/>
           </a:xfrm>
           <a:prstGeom prst="rect">
             <a:avLst/>
@@ -9477,23 +9477,23 @@
         </p:nvSpPr>
         <p:spPr>
           <a:xfrm>
-            <a:off x="9701784" y="5879592"/>
-            <a:ext cx="1737360" cy="365760"/>
-          </a:xfrm>
-          <a:prstGeom prst="rect">
-            <a:avLst/>
-          </a:prstGeom>
-          <a:noFill/>
-        </p:spPr>
-        <p:txBody>
-          <a:bodyPr wrap="square">
-            <a:spAutoFit/>
-          </a:bodyPr>
-          <a:lstStyle/>
-          <a:p>
-            <a:pPr algn="ctr"/>
-            <a:r>
-              <a:rPr sz="1200" b="0" i="0">
+            <a:off x="9701784" y="5477256"/>
+            <a:ext cx="1737360" cy="347472"/>
+          </a:xfrm>
+          <a:prstGeom prst="rect">
+            <a:avLst/>
+          </a:prstGeom>
+          <a:noFill/>
+        </p:spPr>
+        <p:txBody>
+          <a:bodyPr wrap="square">
+            <a:spAutoFit/>
+          </a:bodyPr>
+          <a:lstStyle/>
+          <a:p>
+            <a:pPr algn="ctr"/>
+            <a:r>
+              <a:rPr sz="1100" b="0" i="0">
                 <a:solidFill>
                   <a:srgbClr val="E74C3C"/>
                 </a:solidFill>
@@ -9506,55 +9506,20 @@
       </p:sp>
       <p:sp>
         <p:nvSpPr>
-          <p:cNvPr id="96" name="TextBox 95"/>
-          <p:cNvSpPr txBox="1"/>
-          <p:nvPr/>
-        </p:nvSpPr>
-        <p:spPr>
-          <a:xfrm>
-            <a:off x="320040" y="6400800"/>
-            <a:ext cx="11430000" cy="292608"/>
-          </a:xfrm>
-          <a:prstGeom prst="rect">
-            <a:avLst/>
-          </a:prstGeom>
-          <a:noFill/>
-        </p:spPr>
-        <p:txBody>
-          <a:bodyPr wrap="square">
-            <a:spAutoFit/>
-          </a:bodyPr>
-          <a:lstStyle/>
-          <a:p>
-            <a:pPr algn="l"/>
-            <a:r>
-              <a:rPr sz="1200" b="1" i="0">
-                <a:solidFill>
-                  <a:srgbClr val="00C9B1"/>
-                </a:solidFill>
-                <a:latin typeface="Calibri"/>
-              </a:rPr>
-              <a:t>Overall Score (Out of 10):   Our System → 9.5   |   IBM Watson → 3.2   |   DeepMind → 2.7   |   Practo → 3.8</a:t>
-            </a:r>
-          </a:p>
-        </p:txBody>
-      </p:sp>
-      <p:sp>
-        <p:nvSpPr>
-          <p:cNvPr id="97" name="Rectangle 96"/>
+          <p:cNvPr id="96" name="Rectangle 95"/>
           <p:cNvSpPr/>
           <p:nvPr/>
         </p:nvSpPr>
         <p:spPr>
           <a:xfrm>
-            <a:off x="0" y="6629400"/>
-            <a:ext cx="12188952" cy="228600"/>
-          </a:xfrm>
-          <a:prstGeom prst="rect">
-            <a:avLst/>
-          </a:prstGeom>
-          <a:solidFill>
-            <a:srgbClr val="11263A"/>
+            <a:off x="320040" y="5934456"/>
+            <a:ext cx="10652760" cy="502920"/>
+          </a:xfrm>
+          <a:prstGeom prst="rect">
+            <a:avLst/>
+          </a:prstGeom>
+          <a:solidFill>
+            <a:srgbClr val="00C9B1"/>
           </a:solidFill>
           <a:ln>
             <a:noFill/>
@@ -9584,7 +9549,225 @@
       </p:sp>
       <p:sp>
         <p:nvSpPr>
+          <p:cNvPr id="97" name="TextBox 96"/>
+          <p:cNvSpPr txBox="1"/>
+          <p:nvPr/>
+        </p:nvSpPr>
+        <p:spPr>
+          <a:xfrm>
+            <a:off x="374904" y="6007608"/>
+            <a:ext cx="2834640" cy="365760"/>
+          </a:xfrm>
+          <a:prstGeom prst="rect">
+            <a:avLst/>
+          </a:prstGeom>
+          <a:noFill/>
+        </p:spPr>
+        <p:txBody>
+          <a:bodyPr wrap="square">
+            <a:spAutoFit/>
+          </a:bodyPr>
+          <a:lstStyle/>
+          <a:p>
+            <a:pPr algn="ctr"/>
+            <a:r>
+              <a:rPr sz="1200" b="0" i="0">
+                <a:solidFill>
+                  <a:srgbClr val="0D1B2A"/>
+                </a:solidFill>
+                <a:latin typeface="Calibri"/>
+              </a:rPr>
+              <a:t>🏆 Overall Score (/10)</a:t>
+            </a:r>
+          </a:p>
+        </p:txBody>
+      </p:sp>
+      <p:sp>
+        <p:nvSpPr>
           <p:cNvPr id="98" name="TextBox 97"/>
+          <p:cNvSpPr txBox="1"/>
+          <p:nvPr/>
+        </p:nvSpPr>
+        <p:spPr>
+          <a:xfrm>
+            <a:off x="3392424" y="6007608"/>
+            <a:ext cx="2286000" cy="365760"/>
+          </a:xfrm>
+          <a:prstGeom prst="rect">
+            <a:avLst/>
+          </a:prstGeom>
+          <a:noFill/>
+        </p:spPr>
+        <p:txBody>
+          <a:bodyPr wrap="square">
+            <a:spAutoFit/>
+          </a:bodyPr>
+          <a:lstStyle/>
+          <a:p>
+            <a:pPr algn="ctr"/>
+            <a:r>
+              <a:rPr sz="1400" b="1" i="0">
+                <a:solidFill>
+                  <a:srgbClr val="F39C12"/>
+                </a:solidFill>
+                <a:latin typeface="Calibri"/>
+              </a:rPr>
+              <a:t>9.5 / 10</a:t>
+            </a:r>
+          </a:p>
+        </p:txBody>
+      </p:sp>
+      <p:sp>
+        <p:nvSpPr>
+          <p:cNvPr id="99" name="TextBox 98"/>
+          <p:cNvSpPr txBox="1"/>
+          <p:nvPr/>
+        </p:nvSpPr>
+        <p:spPr>
+          <a:xfrm>
+            <a:off x="5861303" y="6007608"/>
+            <a:ext cx="1737360" cy="365760"/>
+          </a:xfrm>
+          <a:prstGeom prst="rect">
+            <a:avLst/>
+          </a:prstGeom>
+          <a:noFill/>
+        </p:spPr>
+        <p:txBody>
+          <a:bodyPr wrap="square">
+            <a:spAutoFit/>
+          </a:bodyPr>
+          <a:lstStyle/>
+          <a:p>
+            <a:pPr algn="ctr"/>
+            <a:r>
+              <a:rPr sz="1400" b="0" i="0">
+                <a:solidFill>
+                  <a:srgbClr val="FFFFFF"/>
+                </a:solidFill>
+                <a:latin typeface="Calibri"/>
+              </a:rPr>
+              <a:t>3.2 / 10</a:t>
+            </a:r>
+          </a:p>
+        </p:txBody>
+      </p:sp>
+      <p:sp>
+        <p:nvSpPr>
+          <p:cNvPr id="100" name="TextBox 99"/>
+          <p:cNvSpPr txBox="1"/>
+          <p:nvPr/>
+        </p:nvSpPr>
+        <p:spPr>
+          <a:xfrm>
+            <a:off x="7781544" y="6007608"/>
+            <a:ext cx="1737360" cy="365760"/>
+          </a:xfrm>
+          <a:prstGeom prst="rect">
+            <a:avLst/>
+          </a:prstGeom>
+          <a:noFill/>
+        </p:spPr>
+        <p:txBody>
+          <a:bodyPr wrap="square">
+            <a:spAutoFit/>
+          </a:bodyPr>
+          <a:lstStyle/>
+          <a:p>
+            <a:pPr algn="ctr"/>
+            <a:r>
+              <a:rPr sz="1400" b="0" i="0">
+                <a:solidFill>
+                  <a:srgbClr val="FFFFFF"/>
+                </a:solidFill>
+                <a:latin typeface="Calibri"/>
+              </a:rPr>
+              <a:t>2.7 / 10</a:t>
+            </a:r>
+          </a:p>
+        </p:txBody>
+      </p:sp>
+      <p:sp>
+        <p:nvSpPr>
+          <p:cNvPr id="101" name="TextBox 100"/>
+          <p:cNvSpPr txBox="1"/>
+          <p:nvPr/>
+        </p:nvSpPr>
+        <p:spPr>
+          <a:xfrm>
+            <a:off x="9701784" y="6007608"/>
+            <a:ext cx="1737360" cy="365760"/>
+          </a:xfrm>
+          <a:prstGeom prst="rect">
+            <a:avLst/>
+          </a:prstGeom>
+          <a:noFill/>
+        </p:spPr>
+        <p:txBody>
+          <a:bodyPr wrap="square">
+            <a:spAutoFit/>
+          </a:bodyPr>
+          <a:lstStyle/>
+          <a:p>
+            <a:pPr algn="ctr"/>
+            <a:r>
+              <a:rPr sz="1400" b="0" i="0">
+                <a:solidFill>
+                  <a:srgbClr val="FFFFFF"/>
+                </a:solidFill>
+                <a:latin typeface="Calibri"/>
+              </a:rPr>
+              <a:t>3.8 / 10</a:t>
+            </a:r>
+          </a:p>
+        </p:txBody>
+      </p:sp>
+      <p:sp>
+        <p:nvSpPr>
+          <p:cNvPr id="102" name="Rectangle 101"/>
+          <p:cNvSpPr/>
+          <p:nvPr/>
+        </p:nvSpPr>
+        <p:spPr>
+          <a:xfrm>
+            <a:off x="0" y="6629400"/>
+            <a:ext cx="12188952" cy="228600"/>
+          </a:xfrm>
+          <a:prstGeom prst="rect">
+            <a:avLst/>
+          </a:prstGeom>
+          <a:solidFill>
+            <a:srgbClr val="11263A"/>
+          </a:solidFill>
+          <a:ln>
+            <a:noFill/>
+          </a:ln>
+        </p:spPr>
+        <p:style>
+          <a:lnRef idx="1">
+            <a:schemeClr val="accent1"/>
+          </a:lnRef>
+          <a:fillRef idx="3">
+            <a:schemeClr val="accent1"/>
+          </a:fillRef>
+          <a:effectRef idx="2">
+            <a:schemeClr val="accent1"/>
+          </a:effectRef>
+          <a:fontRef idx="minor">
+            <a:schemeClr val="lt1"/>
+          </a:fontRef>
+        </p:style>
+        <p:txBody>
+          <a:bodyPr rtlCol="0" anchor="ctr"/>
+          <a:lstStyle/>
+          <a:p>
+            <a:pPr algn="ctr"/>
+          </a:p>
+        </p:txBody>
+      </p:sp>
+      <p:sp>
+        <p:nvSpPr>
+          <p:cNvPr id="103" name="TextBox 102"/>
           <p:cNvSpPr txBox="1"/>
           <p:nvPr/>
         </p:nvSpPr>
@@ -9619,7 +9802,7 @@
       </p:sp>
       <p:sp>
         <p:nvSpPr>
-          <p:cNvPr id="99" name="TextBox 98"/>
+          <p:cNvPr id="104" name="TextBox 103"/>
           <p:cNvSpPr txBox="1"/>
           <p:nvPr/>
         </p:nvSpPr>
@@ -9654,7 +9837,7 @@
       </p:sp>
       <p:sp>
         <p:nvSpPr>
-          <p:cNvPr id="100" name="TextBox 99"/>
+          <p:cNvPr id="105" name="TextBox 104"/>
           <p:cNvSpPr txBox="1"/>
           <p:nvPr/>
         </p:nvSpPr>
@@ -19328,7 +19511,7 @@
                 </a:solidFill>
                 <a:latin typeface="Calibri"/>
               </a:rPr>
-              <a:t>Slide 16 / 17</a:t>
+              <a:t>Slide 17 / 17</a:t>
             </a:r>
           </a:p>
         </p:txBody>
@@ -26130,7 +26313,7 @@
                 </a:solidFill>
                 <a:latin typeface="Calibri"/>
               </a:rPr>
-              <a:t>Database Architecture  ★</a:t>
+              <a:t>Database Architecture — Collections &amp; Schema  ★</a:t>
             </a:r>
           </a:p>
         </p:txBody>
@@ -26165,7 +26348,7 @@
                 </a:solidFill>
                 <a:latin typeface="Calibri"/>
               </a:rPr>
-              <a:t>MongoDB Atlas — Why NoSQL, How It's Structured, Partitioning Logic</a:t>
+              <a:t>MongoDB Atlas — 6 Collections, Field-Level Schema, Partitioning</a:t>
             </a:r>
           </a:p>
         </p:txBody>
@@ -26178,8 +26361,8 @@
         </p:nvSpPr>
         <p:spPr>
           <a:xfrm>
-            <a:off x="457200" y="1143000"/>
-            <a:ext cx="4572000" cy="347472"/>
+            <a:off x="365760" y="1143000"/>
+            <a:ext cx="5303520" cy="347472"/>
           </a:xfrm>
           <a:prstGeom prst="rect">
             <a:avLst/>
@@ -26194,167 +26377,27 @@
           <a:p>
             <a:pPr algn="l"/>
             <a:r>
-              <a:rPr sz="1500" b="1" i="0">
+              <a:rPr sz="1400" b="1" i="0">
                 <a:solidFill>
                   <a:srgbClr val="00C9B1"/>
                 </a:solidFill>
                 <a:latin typeface="Calibri"/>
               </a:rPr>
-              <a:t>Why MongoDB (NoSQL)?</a:t>
-            </a:r>
-          </a:p>
-        </p:txBody>
-      </p:sp>
-      <p:sp>
-        <p:nvSpPr>
-          <p:cNvPr id="7" name="TextBox 6"/>
-          <p:cNvSpPr txBox="1"/>
-          <p:nvPr/>
-        </p:nvSpPr>
-        <p:spPr>
-          <a:xfrm>
-            <a:off x="457200" y="1554480"/>
-            <a:ext cx="5669280" cy="384048"/>
-          </a:xfrm>
-          <a:prstGeom prst="rect">
-            <a:avLst/>
-          </a:prstGeom>
-          <a:noFill/>
-        </p:spPr>
-        <p:txBody>
-          <a:bodyPr wrap="square">
-            <a:spAutoFit/>
-          </a:bodyPr>
-          <a:lstStyle/>
-          <a:p>
-            <a:pPr algn="l"/>
-            <a:r>
-              <a:rPr sz="1200" b="0" i="0">
-                <a:solidFill>
-                  <a:srgbClr val="B2BEC3"/>
-                </a:solidFill>
-                <a:latin typeface="Calibri"/>
-              </a:rPr>
-              <a:t>  ✦  Variable schema — different vitals per disease type (creatinine for kidney, cholesterol for heart)</a:t>
-            </a:r>
-          </a:p>
-        </p:txBody>
-      </p:sp>
-      <p:sp>
-        <p:nvSpPr>
-          <p:cNvPr id="8" name="TextBox 7"/>
-          <p:cNvSpPr txBox="1"/>
-          <p:nvPr/>
-        </p:nvSpPr>
-        <p:spPr>
-          <a:xfrm>
-            <a:off x="457200" y="1956816"/>
-            <a:ext cx="5669280" cy="384048"/>
-          </a:xfrm>
-          <a:prstGeom prst="rect">
-            <a:avLst/>
-          </a:prstGeom>
-          <a:noFill/>
-        </p:spPr>
-        <p:txBody>
-          <a:bodyPr wrap="square">
-            <a:spAutoFit/>
-          </a:bodyPr>
-          <a:lstStyle/>
-          <a:p>
-            <a:pPr algn="l"/>
-            <a:r>
-              <a:rPr sz="1200" b="0" i="0">
-                <a:solidFill>
-                  <a:srgbClr val="B2BEC3"/>
-                </a:solidFill>
-                <a:latin typeface="Calibri"/>
-              </a:rPr>
-              <a:t>  ✦  Document model maps 1:1 to JSON REST API — zero transformation overhead</a:t>
-            </a:r>
-          </a:p>
-        </p:txBody>
-      </p:sp>
-      <p:sp>
-        <p:nvSpPr>
-          <p:cNvPr id="9" name="TextBox 8"/>
-          <p:cNvSpPr txBox="1"/>
-          <p:nvPr/>
-        </p:nvSpPr>
-        <p:spPr>
-          <a:xfrm>
-            <a:off x="457200" y="2359152"/>
-            <a:ext cx="5669280" cy="384048"/>
-          </a:xfrm>
-          <a:prstGeom prst="rect">
-            <a:avLst/>
-          </a:prstGeom>
-          <a:noFill/>
-        </p:spPr>
-        <p:txBody>
-          <a:bodyPr wrap="square">
-            <a:spAutoFit/>
-          </a:bodyPr>
-          <a:lstStyle/>
-          <a:p>
-            <a:pPr algn="l"/>
-            <a:r>
-              <a:rPr sz="1200" b="0" i="0">
-                <a:solidFill>
-                  <a:srgbClr val="B2BEC3"/>
-                </a:solidFill>
-                <a:latin typeface="Calibri"/>
-              </a:rPr>
-              <a:t>  ✦  Atlas provides auto-sharding, geo-distributed replicas, 99.99% uptime SLA</a:t>
-            </a:r>
-          </a:p>
-        </p:txBody>
-      </p:sp>
-      <p:sp>
-        <p:nvSpPr>
-          <p:cNvPr id="10" name="TextBox 9"/>
-          <p:cNvSpPr txBox="1"/>
-          <p:nvPr/>
-        </p:nvSpPr>
-        <p:spPr>
-          <a:xfrm>
-            <a:off x="457200" y="2761488"/>
-            <a:ext cx="5669280" cy="384048"/>
-          </a:xfrm>
-          <a:prstGeom prst="rect">
-            <a:avLst/>
-          </a:prstGeom>
-          <a:noFill/>
-        </p:spPr>
-        <p:txBody>
-          <a:bodyPr wrap="square">
-            <a:spAutoFit/>
-          </a:bodyPr>
-          <a:lstStyle/>
-          <a:p>
-            <a:pPr algn="l"/>
-            <a:r>
-              <a:rPr sz="1200" b="0" i="0">
-                <a:solidFill>
-                  <a:srgbClr val="B2BEC3"/>
-                </a:solidFill>
-                <a:latin typeface="Calibri"/>
-              </a:rPr>
-              <a:t>  ✦  Indexing + partitioned collections enable O(1) clinical triage lookup</a:t>
-            </a:r>
-          </a:p>
-        </p:txBody>
-      </p:sp>
-      <p:sp>
-        <p:nvSpPr>
-          <p:cNvPr id="11" name="Rectangle 10"/>
+              <a:t>Why MongoDB (NoSQL) over SQL?</a:t>
+            </a:r>
+          </a:p>
+        </p:txBody>
+      </p:sp>
+      <p:sp>
+        <p:nvSpPr>
+          <p:cNvPr id="7" name="Rectangle 6"/>
           <p:cNvSpPr/>
           <p:nvPr/>
         </p:nvSpPr>
         <p:spPr>
           <a:xfrm>
-            <a:off x="457200" y="3401568"/>
-            <a:ext cx="11274552" cy="36576"/>
+            <a:off x="365760" y="1554480"/>
+            <a:ext cx="1371600" cy="502920"/>
           </a:xfrm>
           <a:prstGeom prst="rect">
             <a:avLst/>
@@ -26390,14 +26433,14 @@
       </p:sp>
       <p:sp>
         <p:nvSpPr>
-          <p:cNvPr id="12" name="TextBox 11"/>
-          <p:cNvSpPr txBox="1"/>
-          <p:nvPr/>
-        </p:nvSpPr>
-        <p:spPr>
-          <a:xfrm>
-            <a:off x="457200" y="3520440"/>
-            <a:ext cx="2743200" cy="347472"/>
+          <p:cNvPr id="8" name="TextBox 7"/>
+          <p:cNvSpPr txBox="1"/>
+          <p:nvPr/>
+        </p:nvSpPr>
+        <p:spPr>
+          <a:xfrm>
+            <a:off x="457200" y="1627632"/>
+            <a:ext cx="1280160" cy="365760"/>
           </a:xfrm>
           <a:prstGeom prst="rect">
             <a:avLst/>
@@ -26412,27 +26455,62 @@
           <a:p>
             <a:pPr algn="l"/>
             <a:r>
-              <a:rPr sz="1400" b="1" i="0">
-                <a:solidFill>
-                  <a:srgbClr val="FFFFFF"/>
-                </a:solidFill>
-                <a:latin typeface="Calibri"/>
-              </a:rPr>
-              <a:t>Collections:</a:t>
-            </a:r>
-          </a:p>
-        </p:txBody>
-      </p:sp>
-      <p:sp>
-        <p:nvSpPr>
-          <p:cNvPr id="13" name="Rectangle 12"/>
+              <a:rPr sz="1000" b="1" i="0">
+                <a:solidFill>
+                  <a:srgbClr val="00C9B1"/>
+                </a:solidFill>
+                <a:latin typeface="Calibri"/>
+              </a:rPr>
+              <a:t>Variable Schema</a:t>
+            </a:r>
+          </a:p>
+        </p:txBody>
+      </p:sp>
+      <p:sp>
+        <p:nvSpPr>
+          <p:cNvPr id="9" name="TextBox 8"/>
+          <p:cNvSpPr txBox="1"/>
+          <p:nvPr/>
+        </p:nvSpPr>
+        <p:spPr>
+          <a:xfrm>
+            <a:off x="1874519" y="1609344"/>
+            <a:ext cx="3657600" cy="457200"/>
+          </a:xfrm>
+          <a:prstGeom prst="rect">
+            <a:avLst/>
+          </a:prstGeom>
+          <a:noFill/>
+        </p:spPr>
+        <p:txBody>
+          <a:bodyPr wrap="square">
+            <a:spAutoFit/>
+          </a:bodyPr>
+          <a:lstStyle/>
+          <a:p>
+            <a:pPr algn="l"/>
+            <a:r>
+              <a:rPr sz="1100" b="0" i="0">
+                <a:solidFill>
+                  <a:srgbClr val="B2BEC3"/>
+                </a:solidFill>
+                <a:latin typeface="Calibri"/>
+              </a:rPr>
+              <a:t>Diabetes → HbA1c fields; Heart → Cholesterol. SQL would need NULL columns.</a:t>
+            </a:r>
+          </a:p>
+        </p:txBody>
+      </p:sp>
+      <p:sp>
+        <p:nvSpPr>
+          <p:cNvPr id="10" name="Rectangle 9"/>
           <p:cNvSpPr/>
           <p:nvPr/>
         </p:nvSpPr>
         <p:spPr>
           <a:xfrm>
-            <a:off x="457200" y="3931920"/>
-            <a:ext cx="3657600" cy="1051560"/>
+            <a:off x="365760" y="2194560"/>
+            <a:ext cx="1371600" cy="502920"/>
           </a:xfrm>
           <a:prstGeom prst="rect">
             <a:avLst/>
@@ -26468,20 +26546,90 @@
       </p:sp>
       <p:sp>
         <p:nvSpPr>
-          <p:cNvPr id="14" name="Rectangle 13"/>
+          <p:cNvPr id="11" name="TextBox 10"/>
+          <p:cNvSpPr txBox="1"/>
+          <p:nvPr/>
+        </p:nvSpPr>
+        <p:spPr>
+          <a:xfrm>
+            <a:off x="457200" y="2267712"/>
+            <a:ext cx="1280160" cy="365760"/>
+          </a:xfrm>
+          <a:prstGeom prst="rect">
+            <a:avLst/>
+          </a:prstGeom>
+          <a:noFill/>
+        </p:spPr>
+        <p:txBody>
+          <a:bodyPr wrap="square">
+            <a:spAutoFit/>
+          </a:bodyPr>
+          <a:lstStyle/>
+          <a:p>
+            <a:pPr algn="l"/>
+            <a:r>
+              <a:rPr sz="1000" b="1" i="0">
+                <a:solidFill>
+                  <a:srgbClr val="00C9B1"/>
+                </a:solidFill>
+                <a:latin typeface="Calibri"/>
+              </a:rPr>
+              <a:t>JSON-Native</a:t>
+            </a:r>
+          </a:p>
+        </p:txBody>
+      </p:sp>
+      <p:sp>
+        <p:nvSpPr>
+          <p:cNvPr id="12" name="TextBox 11"/>
+          <p:cNvSpPr txBox="1"/>
+          <p:nvPr/>
+        </p:nvSpPr>
+        <p:spPr>
+          <a:xfrm>
+            <a:off x="1874519" y="2249424"/>
+            <a:ext cx="3657600" cy="457200"/>
+          </a:xfrm>
+          <a:prstGeom prst="rect">
+            <a:avLst/>
+          </a:prstGeom>
+          <a:noFill/>
+        </p:spPr>
+        <p:txBody>
+          <a:bodyPr wrap="square">
+            <a:spAutoFit/>
+          </a:bodyPr>
+          <a:lstStyle/>
+          <a:p>
+            <a:pPr algn="l"/>
+            <a:r>
+              <a:rPr sz="1100" b="0" i="0">
+                <a:solidFill>
+                  <a:srgbClr val="B2BEC3"/>
+                </a:solidFill>
+                <a:latin typeface="Calibri"/>
+              </a:rPr>
+              <a:t>REST API returns JSON. MongoDB stores BSON. Zero transformation needed.</a:t>
+            </a:r>
+          </a:p>
+        </p:txBody>
+      </p:sp>
+      <p:sp>
+        <p:nvSpPr>
+          <p:cNvPr id="13" name="Rectangle 12"/>
           <p:cNvSpPr/>
           <p:nvPr/>
         </p:nvSpPr>
         <p:spPr>
           <a:xfrm>
-            <a:off x="457200" y="3931920"/>
-            <a:ext cx="64008" cy="1051560"/>
-          </a:xfrm>
-          <a:prstGeom prst="rect">
-            <a:avLst/>
-          </a:prstGeom>
-          <a:solidFill>
-            <a:srgbClr val="2E86C1"/>
+            <a:off x="365760" y="2834639"/>
+            <a:ext cx="1371600" cy="502920"/>
+          </a:xfrm>
+          <a:prstGeom prst="rect">
+            <a:avLst/>
+          </a:prstGeom>
+          <a:solidFill>
+            <a:srgbClr val="2D3A4A"/>
           </a:solidFill>
           <a:ln>
             <a:noFill/>
@@ -26511,14 +26659,49 @@
       </p:sp>
       <p:sp>
         <p:nvSpPr>
+          <p:cNvPr id="14" name="TextBox 13"/>
+          <p:cNvSpPr txBox="1"/>
+          <p:nvPr/>
+        </p:nvSpPr>
+        <p:spPr>
+          <a:xfrm>
+            <a:off x="457200" y="2907791"/>
+            <a:ext cx="1280160" cy="365760"/>
+          </a:xfrm>
+          <a:prstGeom prst="rect">
+            <a:avLst/>
+          </a:prstGeom>
+          <a:noFill/>
+        </p:spPr>
+        <p:txBody>
+          <a:bodyPr wrap="square">
+            <a:spAutoFit/>
+          </a:bodyPr>
+          <a:lstStyle/>
+          <a:p>
+            <a:pPr algn="l"/>
+            <a:r>
+              <a:rPr sz="1000" b="1" i="0">
+                <a:solidFill>
+                  <a:srgbClr val="00C9B1"/>
+                </a:solidFill>
+                <a:latin typeface="Calibri"/>
+              </a:rPr>
+              <a:t>Atlas SLA 99.99%</a:t>
+            </a:r>
+          </a:p>
+        </p:txBody>
+      </p:sp>
+      <p:sp>
+        <p:nvSpPr>
           <p:cNvPr id="15" name="TextBox 14"/>
           <p:cNvSpPr txBox="1"/>
           <p:nvPr/>
         </p:nvSpPr>
         <p:spPr>
           <a:xfrm>
-            <a:off x="640080" y="4005072"/>
-            <a:ext cx="3383280" cy="347472"/>
+            <a:off x="1874519" y="2889503"/>
+            <a:ext cx="3657600" cy="457200"/>
           </a:xfrm>
           <a:prstGeom prst="rect">
             <a:avLst/>
@@ -26533,97 +26716,27 @@
           <a:p>
             <a:pPr algn="l"/>
             <a:r>
-              <a:rPr sz="1200" b="1" i="0">
-                <a:solidFill>
-                  <a:srgbClr val="2E86C1"/>
-                </a:solidFill>
-                <a:latin typeface="Calibri"/>
-              </a:rPr>
-              <a:t>patients</a:t>
-            </a:r>
-          </a:p>
-        </p:txBody>
-      </p:sp>
-      <p:sp>
-        <p:nvSpPr>
-          <p:cNvPr id="16" name="TextBox 15"/>
-          <p:cNvSpPr txBox="1"/>
-          <p:nvPr/>
-        </p:nvSpPr>
-        <p:spPr>
-          <a:xfrm>
-            <a:off x="640080" y="4352544"/>
-            <a:ext cx="3383280" cy="274320"/>
-          </a:xfrm>
-          <a:prstGeom prst="rect">
-            <a:avLst/>
-          </a:prstGeom>
-          <a:noFill/>
-        </p:spPr>
-        <p:txBody>
-          <a:bodyPr wrap="square">
-            <a:spAutoFit/>
-          </a:bodyPr>
-          <a:lstStyle/>
-          <a:p>
-            <a:pPr algn="l"/>
-            <a:r>
               <a:rPr sz="1100" b="0" i="0">
                 <a:solidFill>
                   <a:srgbClr val="B2BEC3"/>
                 </a:solidFill>
                 <a:latin typeface="Calibri"/>
               </a:rPr>
-              <a:t>Master Registry</a:t>
-            </a:r>
-          </a:p>
-        </p:txBody>
-      </p:sp>
-      <p:sp>
-        <p:nvSpPr>
-          <p:cNvPr id="17" name="TextBox 16"/>
-          <p:cNvSpPr txBox="1"/>
-          <p:nvPr/>
-        </p:nvSpPr>
-        <p:spPr>
-          <a:xfrm>
-            <a:off x="640080" y="4626864"/>
-            <a:ext cx="3383280" cy="274320"/>
-          </a:xfrm>
-          <a:prstGeom prst="rect">
-            <a:avLst/>
-          </a:prstGeom>
-          <a:noFill/>
-        </p:spPr>
-        <p:txBody>
-          <a:bodyPr wrap="square">
-            <a:spAutoFit/>
-          </a:bodyPr>
-          <a:lstStyle/>
-          <a:p>
-            <a:pPr algn="l"/>
-            <a:r>
-              <a:rPr sz="1100" b="1" i="0">
-                <a:solidFill>
-                  <a:srgbClr val="FFFFFF"/>
-                </a:solidFill>
-                <a:latin typeface="Calibri"/>
-              </a:rPr>
-              <a:t>10,000+  records</a:t>
-            </a:r>
-          </a:p>
-        </p:txBody>
-      </p:sp>
-      <p:sp>
-        <p:nvSpPr>
-          <p:cNvPr id="18" name="Rectangle 17"/>
+              <a:t>Auto-sharding + geo-replicas. No manual DBA required.</a:t>
+            </a:r>
+          </a:p>
+        </p:txBody>
+      </p:sp>
+      <p:sp>
+        <p:nvSpPr>
+          <p:cNvPr id="16" name="Rectangle 15"/>
           <p:cNvSpPr/>
           <p:nvPr/>
         </p:nvSpPr>
         <p:spPr>
           <a:xfrm>
-            <a:off x="4343400" y="3931920"/>
-            <a:ext cx="3657600" cy="1051560"/>
+            <a:off x="365760" y="3474720"/>
+            <a:ext cx="1371600" cy="502920"/>
           </a:xfrm>
           <a:prstGeom prst="rect">
             <a:avLst/>
@@ -26659,20 +26772,125 @@
       </p:sp>
       <p:sp>
         <p:nvSpPr>
-          <p:cNvPr id="19" name="Rectangle 18"/>
+          <p:cNvPr id="17" name="TextBox 16"/>
+          <p:cNvSpPr txBox="1"/>
+          <p:nvPr/>
+        </p:nvSpPr>
+        <p:spPr>
+          <a:xfrm>
+            <a:off x="457200" y="3547872"/>
+            <a:ext cx="1280160" cy="365760"/>
+          </a:xfrm>
+          <a:prstGeom prst="rect">
+            <a:avLst/>
+          </a:prstGeom>
+          <a:noFill/>
+        </p:spPr>
+        <p:txBody>
+          <a:bodyPr wrap="square">
+            <a:spAutoFit/>
+          </a:bodyPr>
+          <a:lstStyle/>
+          <a:p>
+            <a:pPr algn="l"/>
+            <a:r>
+              <a:rPr sz="1000" b="1" i="0">
+                <a:solidFill>
+                  <a:srgbClr val="00C9B1"/>
+                </a:solidFill>
+                <a:latin typeface="Calibri"/>
+              </a:rPr>
+              <a:t>O(1) Triage</a:t>
+            </a:r>
+          </a:p>
+        </p:txBody>
+      </p:sp>
+      <p:sp>
+        <p:nvSpPr>
+          <p:cNvPr id="18" name="TextBox 17"/>
+          <p:cNvSpPr txBox="1"/>
+          <p:nvPr/>
+        </p:nvSpPr>
+        <p:spPr>
+          <a:xfrm>
+            <a:off x="1874519" y="3529584"/>
+            <a:ext cx="3657600" cy="457200"/>
+          </a:xfrm>
+          <a:prstGeom prst="rect">
+            <a:avLst/>
+          </a:prstGeom>
+          <a:noFill/>
+        </p:spPr>
+        <p:txBody>
+          <a:bodyPr wrap="square">
+            <a:spAutoFit/>
+          </a:bodyPr>
+          <a:lstStyle/>
+          <a:p>
+            <a:pPr algn="l"/>
+            <a:r>
+              <a:rPr sz="1100" b="0" i="0">
+                <a:solidFill>
+                  <a:srgbClr val="B2BEC3"/>
+                </a:solidFill>
+                <a:latin typeface="Calibri"/>
+              </a:rPr>
+              <a:t>Partitioned collections → ASHA dashboard reads &lt;5ms vs full 10K scan.</a:t>
+            </a:r>
+          </a:p>
+        </p:txBody>
+      </p:sp>
+      <p:sp>
+        <p:nvSpPr>
+          <p:cNvPr id="19" name="TextBox 18"/>
+          <p:cNvSpPr txBox="1"/>
+          <p:nvPr/>
+        </p:nvSpPr>
+        <p:spPr>
+          <a:xfrm>
+            <a:off x="6035040" y="1143000"/>
+            <a:ext cx="5943600" cy="347472"/>
+          </a:xfrm>
+          <a:prstGeom prst="rect">
+            <a:avLst/>
+          </a:prstGeom>
+          <a:noFill/>
+        </p:spPr>
+        <p:txBody>
+          <a:bodyPr wrap="square">
+            <a:spAutoFit/>
+          </a:bodyPr>
+          <a:lstStyle/>
+          <a:p>
+            <a:pPr algn="l"/>
+            <a:r>
+              <a:rPr sz="1400" b="1" i="0">
+                <a:solidFill>
+                  <a:srgbClr val="FFFFFF"/>
+                </a:solidFill>
+                <a:latin typeface="Calibri"/>
+              </a:rPr>
+              <a:t>6 Collections:</a:t>
+            </a:r>
+          </a:p>
+        </p:txBody>
+      </p:sp>
+      <p:sp>
+        <p:nvSpPr>
+          <p:cNvPr id="20" name="Rectangle 19"/>
           <p:cNvSpPr/>
           <p:nvPr/>
         </p:nvSpPr>
         <p:spPr>
           <a:xfrm>
-            <a:off x="4343400" y="3931920"/>
-            <a:ext cx="64008" cy="1051560"/>
-          </a:xfrm>
-          <a:prstGeom prst="rect">
-            <a:avLst/>
-          </a:prstGeom>
-          <a:solidFill>
-            <a:srgbClr val="00C9B1"/>
+            <a:off x="6035040" y="1572768"/>
+            <a:ext cx="2834640" cy="1417320"/>
+          </a:xfrm>
+          <a:prstGeom prst="rect">
+            <a:avLst/>
+          </a:prstGeom>
+          <a:solidFill>
+            <a:srgbClr val="2D3A4A"/>
           </a:solidFill>
           <a:ln>
             <a:noFill/>
@@ -26702,125 +26920,20 @@
       </p:sp>
       <p:sp>
         <p:nvSpPr>
-          <p:cNvPr id="20" name="TextBox 19"/>
-          <p:cNvSpPr txBox="1"/>
-          <p:nvPr/>
-        </p:nvSpPr>
-        <p:spPr>
-          <a:xfrm>
-            <a:off x="4526280" y="4005072"/>
-            <a:ext cx="3383280" cy="347472"/>
-          </a:xfrm>
-          <a:prstGeom prst="rect">
-            <a:avLst/>
-          </a:prstGeom>
-          <a:noFill/>
-        </p:spPr>
-        <p:txBody>
-          <a:bodyPr wrap="square">
-            <a:spAutoFit/>
-          </a:bodyPr>
-          <a:lstStyle/>
-          <a:p>
-            <a:pPr algn="l"/>
-            <a:r>
-              <a:rPr sz="1200" b="1" i="0">
-                <a:solidFill>
-                  <a:srgbClr val="00C9B1"/>
-                </a:solidFill>
-                <a:latin typeface="Calibri"/>
-              </a:rPr>
-              <a:t>diagnoses</a:t>
-            </a:r>
-          </a:p>
-        </p:txBody>
-      </p:sp>
-      <p:sp>
-        <p:nvSpPr>
-          <p:cNvPr id="21" name="TextBox 20"/>
-          <p:cNvSpPr txBox="1"/>
-          <p:nvPr/>
-        </p:nvSpPr>
-        <p:spPr>
-          <a:xfrm>
-            <a:off x="4526280" y="4352544"/>
-            <a:ext cx="3383280" cy="274320"/>
-          </a:xfrm>
-          <a:prstGeom prst="rect">
-            <a:avLst/>
-          </a:prstGeom>
-          <a:noFill/>
-        </p:spPr>
-        <p:txBody>
-          <a:bodyPr wrap="square">
-            <a:spAutoFit/>
-          </a:bodyPr>
-          <a:lstStyle/>
-          <a:p>
-            <a:pPr algn="l"/>
-            <a:r>
-              <a:rPr sz="1100" b="0" i="0">
-                <a:solidFill>
-                  <a:srgbClr val="B2BEC3"/>
-                </a:solidFill>
-                <a:latin typeface="Calibri"/>
-              </a:rPr>
-              <a:t>ML Predictions + Labs</a:t>
-            </a:r>
-          </a:p>
-        </p:txBody>
-      </p:sp>
-      <p:sp>
-        <p:nvSpPr>
-          <p:cNvPr id="22" name="TextBox 21"/>
-          <p:cNvSpPr txBox="1"/>
-          <p:nvPr/>
-        </p:nvSpPr>
-        <p:spPr>
-          <a:xfrm>
-            <a:off x="4526280" y="4626864"/>
-            <a:ext cx="3383280" cy="274320"/>
-          </a:xfrm>
-          <a:prstGeom prst="rect">
-            <a:avLst/>
-          </a:prstGeom>
-          <a:noFill/>
-        </p:spPr>
-        <p:txBody>
-          <a:bodyPr wrap="square">
-            <a:spAutoFit/>
-          </a:bodyPr>
-          <a:lstStyle/>
-          <a:p>
-            <a:pPr algn="l"/>
-            <a:r>
-              <a:rPr sz="1100" b="1" i="0">
-                <a:solidFill>
-                  <a:srgbClr val="FFFFFF"/>
-                </a:solidFill>
-                <a:latin typeface="Calibri"/>
-              </a:rPr>
-              <a:t>30,000+  records</a:t>
-            </a:r>
-          </a:p>
-        </p:txBody>
-      </p:sp>
-      <p:sp>
-        <p:nvSpPr>
-          <p:cNvPr id="23" name="Rectangle 22"/>
+          <p:cNvPr id="21" name="Rectangle 20"/>
           <p:cNvSpPr/>
           <p:nvPr/>
         </p:nvSpPr>
         <p:spPr>
           <a:xfrm>
-            <a:off x="8229600" y="3931920"/>
-            <a:ext cx="3657600" cy="1051560"/>
-          </a:xfrm>
-          <a:prstGeom prst="rect">
-            <a:avLst/>
-          </a:prstGeom>
-          <a:solidFill>
-            <a:srgbClr val="2D3A4A"/>
+            <a:off x="6035040" y="1572768"/>
+            <a:ext cx="54864" cy="1417320"/>
+          </a:xfrm>
+          <a:prstGeom prst="rect">
+            <a:avLst/>
+          </a:prstGeom>
+          <a:solidFill>
+            <a:srgbClr val="2E86C1"/>
           </a:solidFill>
           <a:ln>
             <a:noFill/>
@@ -26850,20 +26963,125 @@
       </p:sp>
       <p:sp>
         <p:nvSpPr>
-          <p:cNvPr id="24" name="Rectangle 23"/>
+          <p:cNvPr id="22" name="TextBox 21"/>
+          <p:cNvSpPr txBox="1"/>
+          <p:nvPr/>
+        </p:nvSpPr>
+        <p:spPr>
+          <a:xfrm>
+            <a:off x="6172200" y="1645920"/>
+            <a:ext cx="2651760" cy="384048"/>
+          </a:xfrm>
+          <a:prstGeom prst="rect">
+            <a:avLst/>
+          </a:prstGeom>
+          <a:noFill/>
+        </p:spPr>
+        <p:txBody>
+          <a:bodyPr wrap="square">
+            <a:spAutoFit/>
+          </a:bodyPr>
+          <a:lstStyle/>
+          <a:p>
+            <a:pPr algn="l"/>
+            <a:r>
+              <a:rPr sz="1100" b="1" i="0">
+                <a:solidFill>
+                  <a:srgbClr val="2E86C1"/>
+                </a:solidFill>
+                <a:latin typeface="Calibri"/>
+              </a:rPr>
+              <a:t>patients</a:t>
+            </a:r>
+          </a:p>
+        </p:txBody>
+      </p:sp>
+      <p:sp>
+        <p:nvSpPr>
+          <p:cNvPr id="23" name="TextBox 22"/>
+          <p:cNvSpPr txBox="1"/>
+          <p:nvPr/>
+        </p:nvSpPr>
+        <p:spPr>
+          <a:xfrm>
+            <a:off x="6172200" y="2048256"/>
+            <a:ext cx="2651760" cy="320040"/>
+          </a:xfrm>
+          <a:prstGeom prst="rect">
+            <a:avLst/>
+          </a:prstGeom>
+          <a:noFill/>
+        </p:spPr>
+        <p:txBody>
+          <a:bodyPr wrap="square">
+            <a:spAutoFit/>
+          </a:bodyPr>
+          <a:lstStyle/>
+          <a:p>
+            <a:pPr algn="l"/>
+            <a:r>
+              <a:rPr sz="1000" b="0" i="0">
+                <a:solidFill>
+                  <a:srgbClr val="B2BEC3"/>
+                </a:solidFill>
+                <a:latin typeface="Calibri"/>
+              </a:rPr>
+              <a:t>Master Registry</a:t>
+            </a:r>
+          </a:p>
+        </p:txBody>
+      </p:sp>
+      <p:sp>
+        <p:nvSpPr>
+          <p:cNvPr id="24" name="TextBox 23"/>
+          <p:cNvSpPr txBox="1"/>
+          <p:nvPr/>
+        </p:nvSpPr>
+        <p:spPr>
+          <a:xfrm>
+            <a:off x="6172200" y="2395728"/>
+            <a:ext cx="2651760" cy="320040"/>
+          </a:xfrm>
+          <a:prstGeom prst="rect">
+            <a:avLst/>
+          </a:prstGeom>
+          <a:noFill/>
+        </p:spPr>
+        <p:txBody>
+          <a:bodyPr wrap="square">
+            <a:spAutoFit/>
+          </a:bodyPr>
+          <a:lstStyle/>
+          <a:p>
+            <a:pPr algn="l"/>
+            <a:r>
+              <a:rPr sz="1100" b="1" i="0">
+                <a:solidFill>
+                  <a:srgbClr val="FFFFFF"/>
+                </a:solidFill>
+                <a:latin typeface="Calibri"/>
+              </a:rPr>
+              <a:t>10,000+ records</a:t>
+            </a:r>
+          </a:p>
+        </p:txBody>
+      </p:sp>
+      <p:sp>
+        <p:nvSpPr>
+          <p:cNvPr id="25" name="Rectangle 24"/>
           <p:cNvSpPr/>
           <p:nvPr/>
         </p:nvSpPr>
         <p:spPr>
           <a:xfrm>
-            <a:off x="8229600" y="3931920"/>
-            <a:ext cx="64008" cy="1051560"/>
-          </a:xfrm>
-          <a:prstGeom prst="rect">
-            <a:avLst/>
-          </a:prstGeom>
-          <a:solidFill>
-            <a:srgbClr val="27AE60"/>
+            <a:off x="9052559" y="1572768"/>
+            <a:ext cx="2834640" cy="1417320"/>
+          </a:xfrm>
+          <a:prstGeom prst="rect">
+            <a:avLst/>
+          </a:prstGeom>
+          <a:solidFill>
+            <a:srgbClr val="2D3A4A"/>
           </a:solidFill>
           <a:ln>
             <a:noFill/>
@@ -26893,125 +27111,20 @@
       </p:sp>
       <p:sp>
         <p:nvSpPr>
-          <p:cNvPr id="25" name="TextBox 24"/>
-          <p:cNvSpPr txBox="1"/>
-          <p:nvPr/>
-        </p:nvSpPr>
-        <p:spPr>
-          <a:xfrm>
-            <a:off x="8412480" y="4005072"/>
-            <a:ext cx="3383280" cy="347472"/>
-          </a:xfrm>
-          <a:prstGeom prst="rect">
-            <a:avLst/>
-          </a:prstGeom>
-          <a:noFill/>
-        </p:spPr>
-        <p:txBody>
-          <a:bodyPr wrap="square">
-            <a:spAutoFit/>
-          </a:bodyPr>
-          <a:lstStyle/>
-          <a:p>
-            <a:pPr algn="l"/>
-            <a:r>
-              <a:rPr sz="1200" b="1" i="0">
-                <a:solidFill>
-                  <a:srgbClr val="27AE60"/>
-                </a:solidFill>
-                <a:latin typeface="Calibri"/>
-              </a:rPr>
-              <a:t>consultations</a:t>
-            </a:r>
-          </a:p>
-        </p:txBody>
-      </p:sp>
-      <p:sp>
-        <p:nvSpPr>
-          <p:cNvPr id="26" name="TextBox 25"/>
-          <p:cNvSpPr txBox="1"/>
-          <p:nvPr/>
-        </p:nvSpPr>
-        <p:spPr>
-          <a:xfrm>
-            <a:off x="8412480" y="4352544"/>
-            <a:ext cx="3383280" cy="274320"/>
-          </a:xfrm>
-          <a:prstGeom prst="rect">
-            <a:avLst/>
-          </a:prstGeom>
-          <a:noFill/>
-        </p:spPr>
-        <p:txBody>
-          <a:bodyPr wrap="square">
-            <a:spAutoFit/>
-          </a:bodyPr>
-          <a:lstStyle/>
-          <a:p>
-            <a:pPr algn="l"/>
-            <a:r>
-              <a:rPr sz="1100" b="0" i="0">
-                <a:solidFill>
-                  <a:srgbClr val="B2BEC3"/>
-                </a:solidFill>
-                <a:latin typeface="Calibri"/>
-              </a:rPr>
-              <a:t>AI Chat Logs</a:t>
-            </a:r>
-          </a:p>
-        </p:txBody>
-      </p:sp>
-      <p:sp>
-        <p:nvSpPr>
-          <p:cNvPr id="27" name="TextBox 26"/>
-          <p:cNvSpPr txBox="1"/>
-          <p:nvPr/>
-        </p:nvSpPr>
-        <p:spPr>
-          <a:xfrm>
-            <a:off x="8412480" y="4626864"/>
-            <a:ext cx="3383280" cy="274320"/>
-          </a:xfrm>
-          <a:prstGeom prst="rect">
-            <a:avLst/>
-          </a:prstGeom>
-          <a:noFill/>
-        </p:spPr>
-        <p:txBody>
-          <a:bodyPr wrap="square">
-            <a:spAutoFit/>
-          </a:bodyPr>
-          <a:lstStyle/>
-          <a:p>
-            <a:pPr algn="l"/>
-            <a:r>
-              <a:rPr sz="1100" b="1" i="0">
-                <a:solidFill>
-                  <a:srgbClr val="FFFFFF"/>
-                </a:solidFill>
-                <a:latin typeface="Calibri"/>
-              </a:rPr>
-              <a:t>Growing</a:t>
-            </a:r>
-          </a:p>
-        </p:txBody>
-      </p:sp>
-      <p:sp>
-        <p:nvSpPr>
-          <p:cNvPr id="28" name="Rectangle 27"/>
+          <p:cNvPr id="26" name="Rectangle 25"/>
           <p:cNvSpPr/>
           <p:nvPr/>
         </p:nvSpPr>
         <p:spPr>
           <a:xfrm>
-            <a:off x="457200" y="5166360"/>
-            <a:ext cx="3657600" cy="1051560"/>
-          </a:xfrm>
-          <a:prstGeom prst="rect">
-            <a:avLst/>
-          </a:prstGeom>
-          <a:solidFill>
-            <a:srgbClr val="2D3A4A"/>
+            <a:off x="9052559" y="1572768"/>
+            <a:ext cx="54864" cy="1417320"/>
+          </a:xfrm>
+          <a:prstGeom prst="rect">
+            <a:avLst/>
+          </a:prstGeom>
+          <a:solidFill>
+            <a:srgbClr val="00C9B1"/>
           </a:solidFill>
           <a:ln>
             <a:noFill/>
@@ -27041,20 +27154,125 @@
       </p:sp>
       <p:sp>
         <p:nvSpPr>
-          <p:cNvPr id="29" name="Rectangle 28"/>
+          <p:cNvPr id="27" name="TextBox 26"/>
+          <p:cNvSpPr txBox="1"/>
+          <p:nvPr/>
+        </p:nvSpPr>
+        <p:spPr>
+          <a:xfrm>
+            <a:off x="9189719" y="1645920"/>
+            <a:ext cx="2651760" cy="384048"/>
+          </a:xfrm>
+          <a:prstGeom prst="rect">
+            <a:avLst/>
+          </a:prstGeom>
+          <a:noFill/>
+        </p:spPr>
+        <p:txBody>
+          <a:bodyPr wrap="square">
+            <a:spAutoFit/>
+          </a:bodyPr>
+          <a:lstStyle/>
+          <a:p>
+            <a:pPr algn="l"/>
+            <a:r>
+              <a:rPr sz="1100" b="1" i="0">
+                <a:solidFill>
+                  <a:srgbClr val="00C9B1"/>
+                </a:solidFill>
+                <a:latin typeface="Calibri"/>
+              </a:rPr>
+              <a:t>diagnoses</a:t>
+            </a:r>
+          </a:p>
+        </p:txBody>
+      </p:sp>
+      <p:sp>
+        <p:nvSpPr>
+          <p:cNvPr id="28" name="TextBox 27"/>
+          <p:cNvSpPr txBox="1"/>
+          <p:nvPr/>
+        </p:nvSpPr>
+        <p:spPr>
+          <a:xfrm>
+            <a:off x="9189719" y="2048256"/>
+            <a:ext cx="2651760" cy="320040"/>
+          </a:xfrm>
+          <a:prstGeom prst="rect">
+            <a:avLst/>
+          </a:prstGeom>
+          <a:noFill/>
+        </p:spPr>
+        <p:txBody>
+          <a:bodyPr wrap="square">
+            <a:spAutoFit/>
+          </a:bodyPr>
+          <a:lstStyle/>
+          <a:p>
+            <a:pPr algn="l"/>
+            <a:r>
+              <a:rPr sz="1000" b="0" i="0">
+                <a:solidFill>
+                  <a:srgbClr val="B2BEC3"/>
+                </a:solidFill>
+                <a:latin typeface="Calibri"/>
+              </a:rPr>
+              <a:t>ML Predictions + Labs</a:t>
+            </a:r>
+          </a:p>
+        </p:txBody>
+      </p:sp>
+      <p:sp>
+        <p:nvSpPr>
+          <p:cNvPr id="29" name="TextBox 28"/>
+          <p:cNvSpPr txBox="1"/>
+          <p:nvPr/>
+        </p:nvSpPr>
+        <p:spPr>
+          <a:xfrm>
+            <a:off x="9189719" y="2395728"/>
+            <a:ext cx="2651760" cy="320040"/>
+          </a:xfrm>
+          <a:prstGeom prst="rect">
+            <a:avLst/>
+          </a:prstGeom>
+          <a:noFill/>
+        </p:spPr>
+        <p:txBody>
+          <a:bodyPr wrap="square">
+            <a:spAutoFit/>
+          </a:bodyPr>
+          <a:lstStyle/>
+          <a:p>
+            <a:pPr algn="l"/>
+            <a:r>
+              <a:rPr sz="1100" b="1" i="0">
+                <a:solidFill>
+                  <a:srgbClr val="FFFFFF"/>
+                </a:solidFill>
+                <a:latin typeface="Calibri"/>
+              </a:rPr>
+              <a:t>30,000+ records</a:t>
+            </a:r>
+          </a:p>
+        </p:txBody>
+      </p:sp>
+      <p:sp>
+        <p:nvSpPr>
+          <p:cNvPr id="30" name="Rectangle 29"/>
           <p:cNvSpPr/>
           <p:nvPr/>
         </p:nvSpPr>
         <p:spPr>
           <a:xfrm>
-            <a:off x="457200" y="5166360"/>
-            <a:ext cx="64008" cy="1051560"/>
-          </a:xfrm>
-          <a:prstGeom prst="rect">
-            <a:avLst/>
-          </a:prstGeom>
-          <a:solidFill>
-            <a:srgbClr val="E74C3C"/>
+            <a:off x="6035040" y="3218688"/>
+            <a:ext cx="2834640" cy="1417320"/>
+          </a:xfrm>
+          <a:prstGeom prst="rect">
+            <a:avLst/>
+          </a:prstGeom>
+          <a:solidFill>
+            <a:srgbClr val="2D3A4A"/>
           </a:solidFill>
           <a:ln>
             <a:noFill/>
@@ -27084,125 +27302,20 @@
       </p:sp>
       <p:sp>
         <p:nvSpPr>
-          <p:cNvPr id="30" name="TextBox 29"/>
-          <p:cNvSpPr txBox="1"/>
-          <p:nvPr/>
-        </p:nvSpPr>
-        <p:spPr>
-          <a:xfrm>
-            <a:off x="640080" y="5239512"/>
-            <a:ext cx="3383280" cy="347472"/>
-          </a:xfrm>
-          <a:prstGeom prst="rect">
-            <a:avLst/>
-          </a:prstGeom>
-          <a:noFill/>
-        </p:spPr>
-        <p:txBody>
-          <a:bodyPr wrap="square">
-            <a:spAutoFit/>
-          </a:bodyPr>
-          <a:lstStyle/>
-          <a:p>
-            <a:pPr algn="l"/>
-            <a:r>
-              <a:rPr sz="1200" b="1" i="0">
-                <a:solidFill>
-                  <a:srgbClr val="E74C3C"/>
-                </a:solidFill>
-                <a:latin typeface="Calibri"/>
-              </a:rPr>
-              <a:t>patients_critical</a:t>
-            </a:r>
-          </a:p>
-        </p:txBody>
-      </p:sp>
-      <p:sp>
-        <p:nvSpPr>
-          <p:cNvPr id="31" name="TextBox 30"/>
-          <p:cNvSpPr txBox="1"/>
-          <p:nvPr/>
-        </p:nvSpPr>
-        <p:spPr>
-          <a:xfrm>
-            <a:off x="640080" y="5586984"/>
-            <a:ext cx="3383280" cy="274320"/>
-          </a:xfrm>
-          <a:prstGeom prst="rect">
-            <a:avLst/>
-          </a:prstGeom>
-          <a:noFill/>
-        </p:spPr>
-        <p:txBody>
-          <a:bodyPr wrap="square">
-            <a:spAutoFit/>
-          </a:bodyPr>
-          <a:lstStyle/>
-          <a:p>
-            <a:pPr algn="l"/>
-            <a:r>
-              <a:rPr sz="1100" b="0" i="0">
-                <a:solidFill>
-                  <a:srgbClr val="B2BEC3"/>
-                </a:solidFill>
-                <a:latin typeface="Calibri"/>
-              </a:rPr>
-              <a:t>🔴 Glucose &gt; 180</a:t>
-            </a:r>
-          </a:p>
-        </p:txBody>
-      </p:sp>
-      <p:sp>
-        <p:nvSpPr>
-          <p:cNvPr id="32" name="TextBox 31"/>
-          <p:cNvSpPr txBox="1"/>
-          <p:nvPr/>
-        </p:nvSpPr>
-        <p:spPr>
-          <a:xfrm>
-            <a:off x="640080" y="5861304"/>
-            <a:ext cx="3383280" cy="274320"/>
-          </a:xfrm>
-          <a:prstGeom prst="rect">
-            <a:avLst/>
-          </a:prstGeom>
-          <a:noFill/>
-        </p:spPr>
-        <p:txBody>
-          <a:bodyPr wrap="square">
-            <a:spAutoFit/>
-          </a:bodyPr>
-          <a:lstStyle/>
-          <a:p>
-            <a:pPr algn="l"/>
-            <a:r>
-              <a:rPr sz="1100" b="1" i="0">
-                <a:solidFill>
-                  <a:srgbClr val="FFFFFF"/>
-                </a:solidFill>
-                <a:latin typeface="Calibri"/>
-              </a:rPr>
-              <a:t>~2,800  records</a:t>
-            </a:r>
-          </a:p>
-        </p:txBody>
-      </p:sp>
-      <p:sp>
-        <p:nvSpPr>
-          <p:cNvPr id="33" name="Rectangle 32"/>
+          <p:cNvPr id="31" name="Rectangle 30"/>
           <p:cNvSpPr/>
           <p:nvPr/>
         </p:nvSpPr>
         <p:spPr>
           <a:xfrm>
-            <a:off x="4343400" y="5166360"/>
-            <a:ext cx="3657600" cy="1051560"/>
-          </a:xfrm>
-          <a:prstGeom prst="rect">
-            <a:avLst/>
-          </a:prstGeom>
-          <a:solidFill>
-            <a:srgbClr val="2D3A4A"/>
+            <a:off x="6035040" y="3218688"/>
+            <a:ext cx="54864" cy="1417320"/>
+          </a:xfrm>
+          <a:prstGeom prst="rect">
+            <a:avLst/>
+          </a:prstGeom>
+          <a:solidFill>
+            <a:srgbClr val="27AE60"/>
           </a:solidFill>
           <a:ln>
             <a:noFill/>
@@ -27232,20 +27345,125 @@
       </p:sp>
       <p:sp>
         <p:nvSpPr>
-          <p:cNvPr id="34" name="Rectangle 33"/>
+          <p:cNvPr id="32" name="TextBox 31"/>
+          <p:cNvSpPr txBox="1"/>
+          <p:nvPr/>
+        </p:nvSpPr>
+        <p:spPr>
+          <a:xfrm>
+            <a:off x="6172200" y="3291840"/>
+            <a:ext cx="2651760" cy="384048"/>
+          </a:xfrm>
+          <a:prstGeom prst="rect">
+            <a:avLst/>
+          </a:prstGeom>
+          <a:noFill/>
+        </p:spPr>
+        <p:txBody>
+          <a:bodyPr wrap="square">
+            <a:spAutoFit/>
+          </a:bodyPr>
+          <a:lstStyle/>
+          <a:p>
+            <a:pPr algn="l"/>
+            <a:r>
+              <a:rPr sz="1100" b="1" i="0">
+                <a:solidFill>
+                  <a:srgbClr val="27AE60"/>
+                </a:solidFill>
+                <a:latin typeface="Calibri"/>
+              </a:rPr>
+              <a:t>consultations</a:t>
+            </a:r>
+          </a:p>
+        </p:txBody>
+      </p:sp>
+      <p:sp>
+        <p:nvSpPr>
+          <p:cNvPr id="33" name="TextBox 32"/>
+          <p:cNvSpPr txBox="1"/>
+          <p:nvPr/>
+        </p:nvSpPr>
+        <p:spPr>
+          <a:xfrm>
+            <a:off x="6172200" y="3694176"/>
+            <a:ext cx="2651760" cy="320040"/>
+          </a:xfrm>
+          <a:prstGeom prst="rect">
+            <a:avLst/>
+          </a:prstGeom>
+          <a:noFill/>
+        </p:spPr>
+        <p:txBody>
+          <a:bodyPr wrap="square">
+            <a:spAutoFit/>
+          </a:bodyPr>
+          <a:lstStyle/>
+          <a:p>
+            <a:pPr algn="l"/>
+            <a:r>
+              <a:rPr sz="1000" b="0" i="0">
+                <a:solidFill>
+                  <a:srgbClr val="B2BEC3"/>
+                </a:solidFill>
+                <a:latin typeface="Calibri"/>
+              </a:rPr>
+              <a:t>AI Chat Logs</a:t>
+            </a:r>
+          </a:p>
+        </p:txBody>
+      </p:sp>
+      <p:sp>
+        <p:nvSpPr>
+          <p:cNvPr id="34" name="TextBox 33"/>
+          <p:cNvSpPr txBox="1"/>
+          <p:nvPr/>
+        </p:nvSpPr>
+        <p:spPr>
+          <a:xfrm>
+            <a:off x="6172200" y="4041648"/>
+            <a:ext cx="2651760" cy="320040"/>
+          </a:xfrm>
+          <a:prstGeom prst="rect">
+            <a:avLst/>
+          </a:prstGeom>
+          <a:noFill/>
+        </p:spPr>
+        <p:txBody>
+          <a:bodyPr wrap="square">
+            <a:spAutoFit/>
+          </a:bodyPr>
+          <a:lstStyle/>
+          <a:p>
+            <a:pPr algn="l"/>
+            <a:r>
+              <a:rPr sz="1100" b="1" i="0">
+                <a:solidFill>
+                  <a:srgbClr val="FFFFFF"/>
+                </a:solidFill>
+                <a:latin typeface="Calibri"/>
+              </a:rPr>
+              <a:t>Growing</a:t>
+            </a:r>
+          </a:p>
+        </p:txBody>
+      </p:sp>
+      <p:sp>
+        <p:nvSpPr>
+          <p:cNvPr id="35" name="Rectangle 34"/>
           <p:cNvSpPr/>
           <p:nvPr/>
         </p:nvSpPr>
         <p:spPr>
           <a:xfrm>
-            <a:off x="4343400" y="5166360"/>
-            <a:ext cx="64008" cy="1051560"/>
-          </a:xfrm>
-          <a:prstGeom prst="rect">
-            <a:avLst/>
-          </a:prstGeom>
-          <a:solidFill>
-            <a:srgbClr val="F39C12"/>
+            <a:off x="9052559" y="3218688"/>
+            <a:ext cx="2834640" cy="1417320"/>
+          </a:xfrm>
+          <a:prstGeom prst="rect">
+            <a:avLst/>
+          </a:prstGeom>
+          <a:solidFill>
+            <a:srgbClr val="2D3A4A"/>
           </a:solidFill>
           <a:ln>
             <a:noFill/>
@@ -27275,125 +27493,20 @@
       </p:sp>
       <p:sp>
         <p:nvSpPr>
-          <p:cNvPr id="35" name="TextBox 34"/>
-          <p:cNvSpPr txBox="1"/>
-          <p:nvPr/>
-        </p:nvSpPr>
-        <p:spPr>
-          <a:xfrm>
-            <a:off x="4526280" y="5239512"/>
-            <a:ext cx="3383280" cy="347472"/>
-          </a:xfrm>
-          <a:prstGeom prst="rect">
-            <a:avLst/>
-          </a:prstGeom>
-          <a:noFill/>
-        </p:spPr>
-        <p:txBody>
-          <a:bodyPr wrap="square">
-            <a:spAutoFit/>
-          </a:bodyPr>
-          <a:lstStyle/>
-          <a:p>
-            <a:pPr algn="l"/>
-            <a:r>
-              <a:rPr sz="1200" b="1" i="0">
-                <a:solidFill>
-                  <a:srgbClr val="F39C12"/>
-                </a:solidFill>
-                <a:latin typeface="Calibri"/>
-              </a:rPr>
-              <a:t>patients_monitoring</a:t>
-            </a:r>
-          </a:p>
-        </p:txBody>
-      </p:sp>
-      <p:sp>
-        <p:nvSpPr>
-          <p:cNvPr id="36" name="TextBox 35"/>
-          <p:cNvSpPr txBox="1"/>
-          <p:nvPr/>
-        </p:nvSpPr>
-        <p:spPr>
-          <a:xfrm>
-            <a:off x="4526280" y="5586984"/>
-            <a:ext cx="3383280" cy="274320"/>
-          </a:xfrm>
-          <a:prstGeom prst="rect">
-            <a:avLst/>
-          </a:prstGeom>
-          <a:noFill/>
-        </p:spPr>
-        <p:txBody>
-          <a:bodyPr wrap="square">
-            <a:spAutoFit/>
-          </a:bodyPr>
-          <a:lstStyle/>
-          <a:p>
-            <a:pPr algn="l"/>
-            <a:r>
-              <a:rPr sz="1100" b="0" i="0">
-                <a:solidFill>
-                  <a:srgbClr val="B2BEC3"/>
-                </a:solidFill>
-                <a:latin typeface="Calibri"/>
-              </a:rPr>
-              <a:t>🟡 Glucose &gt; 120</a:t>
-            </a:r>
-          </a:p>
-        </p:txBody>
-      </p:sp>
-      <p:sp>
-        <p:nvSpPr>
-          <p:cNvPr id="37" name="TextBox 36"/>
-          <p:cNvSpPr txBox="1"/>
-          <p:nvPr/>
-        </p:nvSpPr>
-        <p:spPr>
-          <a:xfrm>
-            <a:off x="4526280" y="5861304"/>
-            <a:ext cx="3383280" cy="274320"/>
-          </a:xfrm>
-          <a:prstGeom prst="rect">
-            <a:avLst/>
-          </a:prstGeom>
-          <a:noFill/>
-        </p:spPr>
-        <p:txBody>
-          <a:bodyPr wrap="square">
-            <a:spAutoFit/>
-          </a:bodyPr>
-          <a:lstStyle/>
-          <a:p>
-            <a:pPr algn="l"/>
-            <a:r>
-              <a:rPr sz="1100" b="1" i="0">
-                <a:solidFill>
-                  <a:srgbClr val="FFFFFF"/>
-                </a:solidFill>
-                <a:latin typeface="Calibri"/>
-              </a:rPr>
-              <a:t>~4,100  records</a:t>
-            </a:r>
-          </a:p>
-        </p:txBody>
-      </p:sp>
-      <p:sp>
-        <p:nvSpPr>
-          <p:cNvPr id="38" name="Rectangle 37"/>
+          <p:cNvPr id="36" name="Rectangle 35"/>
           <p:cNvSpPr/>
           <p:nvPr/>
         </p:nvSpPr>
         <p:spPr>
           <a:xfrm>
-            <a:off x="8229600" y="5166360"/>
-            <a:ext cx="3657600" cy="1051560"/>
-          </a:xfrm>
-          <a:prstGeom prst="rect">
-            <a:avLst/>
-          </a:prstGeom>
-          <a:solidFill>
-            <a:srgbClr val="2D3A4A"/>
+            <a:off x="9052559" y="3218688"/>
+            <a:ext cx="54864" cy="1417320"/>
+          </a:xfrm>
+          <a:prstGeom prst="rect">
+            <a:avLst/>
+          </a:prstGeom>
+          <a:solidFill>
+            <a:srgbClr val="E74C3C"/>
           </a:solidFill>
           <a:ln>
             <a:noFill/>
@@ -27423,20 +27536,125 @@
       </p:sp>
       <p:sp>
         <p:nvSpPr>
-          <p:cNvPr id="39" name="Rectangle 38"/>
+          <p:cNvPr id="37" name="TextBox 36"/>
+          <p:cNvSpPr txBox="1"/>
+          <p:nvPr/>
+        </p:nvSpPr>
+        <p:spPr>
+          <a:xfrm>
+            <a:off x="9189719" y="3291840"/>
+            <a:ext cx="2651760" cy="384048"/>
+          </a:xfrm>
+          <a:prstGeom prst="rect">
+            <a:avLst/>
+          </a:prstGeom>
+          <a:noFill/>
+        </p:spPr>
+        <p:txBody>
+          <a:bodyPr wrap="square">
+            <a:spAutoFit/>
+          </a:bodyPr>
+          <a:lstStyle/>
+          <a:p>
+            <a:pPr algn="l"/>
+            <a:r>
+              <a:rPr sz="1100" b="1" i="0">
+                <a:solidFill>
+                  <a:srgbClr val="E74C3C"/>
+                </a:solidFill>
+                <a:latin typeface="Calibri"/>
+              </a:rPr>
+              <a:t>patients_critical</a:t>
+            </a:r>
+          </a:p>
+        </p:txBody>
+      </p:sp>
+      <p:sp>
+        <p:nvSpPr>
+          <p:cNvPr id="38" name="TextBox 37"/>
+          <p:cNvSpPr txBox="1"/>
+          <p:nvPr/>
+        </p:nvSpPr>
+        <p:spPr>
+          <a:xfrm>
+            <a:off x="9189719" y="3694176"/>
+            <a:ext cx="2651760" cy="320040"/>
+          </a:xfrm>
+          <a:prstGeom prst="rect">
+            <a:avLst/>
+          </a:prstGeom>
+          <a:noFill/>
+        </p:spPr>
+        <p:txBody>
+          <a:bodyPr wrap="square">
+            <a:spAutoFit/>
+          </a:bodyPr>
+          <a:lstStyle/>
+          <a:p>
+            <a:pPr algn="l"/>
+            <a:r>
+              <a:rPr sz="1000" b="0" i="0">
+                <a:solidFill>
+                  <a:srgbClr val="B2BEC3"/>
+                </a:solidFill>
+                <a:latin typeface="Calibri"/>
+              </a:rPr>
+              <a:t>🔴 Glucose &gt; 180</a:t>
+            </a:r>
+          </a:p>
+        </p:txBody>
+      </p:sp>
+      <p:sp>
+        <p:nvSpPr>
+          <p:cNvPr id="39" name="TextBox 38"/>
+          <p:cNvSpPr txBox="1"/>
+          <p:nvPr/>
+        </p:nvSpPr>
+        <p:spPr>
+          <a:xfrm>
+            <a:off x="9189719" y="4041648"/>
+            <a:ext cx="2651760" cy="320040"/>
+          </a:xfrm>
+          <a:prstGeom prst="rect">
+            <a:avLst/>
+          </a:prstGeom>
+          <a:noFill/>
+        </p:spPr>
+        <p:txBody>
+          <a:bodyPr wrap="square">
+            <a:spAutoFit/>
+          </a:bodyPr>
+          <a:lstStyle/>
+          <a:p>
+            <a:pPr algn="l"/>
+            <a:r>
+              <a:rPr sz="1100" b="1" i="0">
+                <a:solidFill>
+                  <a:srgbClr val="FFFFFF"/>
+                </a:solidFill>
+                <a:latin typeface="Calibri"/>
+              </a:rPr>
+              <a:t>~2,800 records</a:t>
+            </a:r>
+          </a:p>
+        </p:txBody>
+      </p:sp>
+      <p:sp>
+        <p:nvSpPr>
+          <p:cNvPr id="40" name="Rectangle 39"/>
           <p:cNvSpPr/>
           <p:nvPr/>
         </p:nvSpPr>
         <p:spPr>
           <a:xfrm>
-            <a:off x="8229600" y="5166360"/>
-            <a:ext cx="64008" cy="1051560"/>
-          </a:xfrm>
-          <a:prstGeom prst="rect">
-            <a:avLst/>
-          </a:prstGeom>
-          <a:solidFill>
-            <a:srgbClr val="27AE60"/>
+            <a:off x="6035040" y="4864608"/>
+            <a:ext cx="2834640" cy="1417320"/>
+          </a:xfrm>
+          <a:prstGeom prst="rect">
+            <a:avLst/>
+          </a:prstGeom>
+          <a:solidFill>
+            <a:srgbClr val="2D3A4A"/>
           </a:solidFill>
           <a:ln>
             <a:noFill/>
@@ -27466,125 +27684,20 @@
       </p:sp>
       <p:sp>
         <p:nvSpPr>
-          <p:cNvPr id="40" name="TextBox 39"/>
-          <p:cNvSpPr txBox="1"/>
-          <p:nvPr/>
-        </p:nvSpPr>
-        <p:spPr>
-          <a:xfrm>
-            <a:off x="8412480" y="5239512"/>
-            <a:ext cx="3383280" cy="347472"/>
-          </a:xfrm>
-          <a:prstGeom prst="rect">
-            <a:avLst/>
-          </a:prstGeom>
-          <a:noFill/>
-        </p:spPr>
-        <p:txBody>
-          <a:bodyPr wrap="square">
-            <a:spAutoFit/>
-          </a:bodyPr>
-          <a:lstStyle/>
-          <a:p>
-            <a:pPr algn="l"/>
-            <a:r>
-              <a:rPr sz="1200" b="1" i="0">
-                <a:solidFill>
-                  <a:srgbClr val="27AE60"/>
-                </a:solidFill>
-                <a:latin typeface="Calibri"/>
-              </a:rPr>
-              <a:t>patients_optimal</a:t>
-            </a:r>
-          </a:p>
-        </p:txBody>
-      </p:sp>
-      <p:sp>
-        <p:nvSpPr>
-          <p:cNvPr id="41" name="TextBox 40"/>
-          <p:cNvSpPr txBox="1"/>
-          <p:nvPr/>
-        </p:nvSpPr>
-        <p:spPr>
-          <a:xfrm>
-            <a:off x="8412480" y="5586984"/>
-            <a:ext cx="3383280" cy="274320"/>
-          </a:xfrm>
-          <a:prstGeom prst="rect">
-            <a:avLst/>
-          </a:prstGeom>
-          <a:noFill/>
-        </p:spPr>
-        <p:txBody>
-          <a:bodyPr wrap="square">
-            <a:spAutoFit/>
-          </a:bodyPr>
-          <a:lstStyle/>
-          <a:p>
-            <a:pPr algn="l"/>
-            <a:r>
-              <a:rPr sz="1100" b="0" i="0">
-                <a:solidFill>
-                  <a:srgbClr val="B2BEC3"/>
-                </a:solidFill>
-                <a:latin typeface="Calibri"/>
-              </a:rPr>
-              <a:t>🟢 Stable Patients</a:t>
-            </a:r>
-          </a:p>
-        </p:txBody>
-      </p:sp>
-      <p:sp>
-        <p:nvSpPr>
-          <p:cNvPr id="42" name="TextBox 41"/>
-          <p:cNvSpPr txBox="1"/>
-          <p:nvPr/>
-        </p:nvSpPr>
-        <p:spPr>
-          <a:xfrm>
-            <a:off x="8412480" y="5861304"/>
-            <a:ext cx="3383280" cy="274320"/>
-          </a:xfrm>
-          <a:prstGeom prst="rect">
-            <a:avLst/>
-          </a:prstGeom>
-          <a:noFill/>
-        </p:spPr>
-        <p:txBody>
-          <a:bodyPr wrap="square">
-            <a:spAutoFit/>
-          </a:bodyPr>
-          <a:lstStyle/>
-          <a:p>
-            <a:pPr algn="l"/>
-            <a:r>
-              <a:rPr sz="1100" b="1" i="0">
-                <a:solidFill>
-                  <a:srgbClr val="FFFFFF"/>
-                </a:solidFill>
-                <a:latin typeface="Calibri"/>
-              </a:rPr>
-              <a:t>~3,100  records</a:t>
-            </a:r>
-          </a:p>
-        </p:txBody>
-      </p:sp>
-      <p:sp>
-        <p:nvSpPr>
-          <p:cNvPr id="43" name="Rectangle 42"/>
+          <p:cNvPr id="41" name="Rectangle 40"/>
           <p:cNvSpPr/>
           <p:nvPr/>
         </p:nvSpPr>
         <p:spPr>
           <a:xfrm>
-            <a:off x="0" y="6629400"/>
-            <a:ext cx="12188952" cy="228600"/>
-          </a:xfrm>
-          <a:prstGeom prst="rect">
-            <a:avLst/>
-          </a:prstGeom>
-          <a:solidFill>
-            <a:srgbClr val="11263A"/>
+            <a:off x="6035040" y="4864608"/>
+            <a:ext cx="54864" cy="1417320"/>
+          </a:xfrm>
+          <a:prstGeom prst="rect">
+            <a:avLst/>
+          </a:prstGeom>
+          <a:solidFill>
+            <a:srgbClr val="F39C12"/>
           </a:solidFill>
           <a:ln>
             <a:noFill/>
@@ -27614,7 +27727,572 @@
       </p:sp>
       <p:sp>
         <p:nvSpPr>
+          <p:cNvPr id="42" name="TextBox 41"/>
+          <p:cNvSpPr txBox="1"/>
+          <p:nvPr/>
+        </p:nvSpPr>
+        <p:spPr>
+          <a:xfrm>
+            <a:off x="6172200" y="4937760"/>
+            <a:ext cx="2651760" cy="384048"/>
+          </a:xfrm>
+          <a:prstGeom prst="rect">
+            <a:avLst/>
+          </a:prstGeom>
+          <a:noFill/>
+        </p:spPr>
+        <p:txBody>
+          <a:bodyPr wrap="square">
+            <a:spAutoFit/>
+          </a:bodyPr>
+          <a:lstStyle/>
+          <a:p>
+            <a:pPr algn="l"/>
+            <a:r>
+              <a:rPr sz="1100" b="1" i="0">
+                <a:solidFill>
+                  <a:srgbClr val="F39C12"/>
+                </a:solidFill>
+                <a:latin typeface="Calibri"/>
+              </a:rPr>
+              <a:t>patients_monitoring</a:t>
+            </a:r>
+          </a:p>
+        </p:txBody>
+      </p:sp>
+      <p:sp>
+        <p:nvSpPr>
+          <p:cNvPr id="43" name="TextBox 42"/>
+          <p:cNvSpPr txBox="1"/>
+          <p:nvPr/>
+        </p:nvSpPr>
+        <p:spPr>
+          <a:xfrm>
+            <a:off x="6172200" y="5340096"/>
+            <a:ext cx="2651760" cy="320040"/>
+          </a:xfrm>
+          <a:prstGeom prst="rect">
+            <a:avLst/>
+          </a:prstGeom>
+          <a:noFill/>
+        </p:spPr>
+        <p:txBody>
+          <a:bodyPr wrap="square">
+            <a:spAutoFit/>
+          </a:bodyPr>
+          <a:lstStyle/>
+          <a:p>
+            <a:pPr algn="l"/>
+            <a:r>
+              <a:rPr sz="1000" b="0" i="0">
+                <a:solidFill>
+                  <a:srgbClr val="B2BEC3"/>
+                </a:solidFill>
+                <a:latin typeface="Calibri"/>
+              </a:rPr>
+              <a:t>🟡 Glucose 120-180</a:t>
+            </a:r>
+          </a:p>
+        </p:txBody>
+      </p:sp>
+      <p:sp>
+        <p:nvSpPr>
           <p:cNvPr id="44" name="TextBox 43"/>
+          <p:cNvSpPr txBox="1"/>
+          <p:nvPr/>
+        </p:nvSpPr>
+        <p:spPr>
+          <a:xfrm>
+            <a:off x="6172200" y="5687568"/>
+            <a:ext cx="2651760" cy="320040"/>
+          </a:xfrm>
+          <a:prstGeom prst="rect">
+            <a:avLst/>
+          </a:prstGeom>
+          <a:noFill/>
+        </p:spPr>
+        <p:txBody>
+          <a:bodyPr wrap="square">
+            <a:spAutoFit/>
+          </a:bodyPr>
+          <a:lstStyle/>
+          <a:p>
+            <a:pPr algn="l"/>
+            <a:r>
+              <a:rPr sz="1100" b="1" i="0">
+                <a:solidFill>
+                  <a:srgbClr val="FFFFFF"/>
+                </a:solidFill>
+                <a:latin typeface="Calibri"/>
+              </a:rPr>
+              <a:t>~4,100 records</a:t>
+            </a:r>
+          </a:p>
+        </p:txBody>
+      </p:sp>
+      <p:sp>
+        <p:nvSpPr>
+          <p:cNvPr id="45" name="Rectangle 44"/>
+          <p:cNvSpPr/>
+          <p:nvPr/>
+        </p:nvSpPr>
+        <p:spPr>
+          <a:xfrm>
+            <a:off x="9052559" y="4864608"/>
+            <a:ext cx="2834640" cy="1417320"/>
+          </a:xfrm>
+          <a:prstGeom prst="rect">
+            <a:avLst/>
+          </a:prstGeom>
+          <a:solidFill>
+            <a:srgbClr val="2D3A4A"/>
+          </a:solidFill>
+          <a:ln>
+            <a:noFill/>
+          </a:ln>
+        </p:spPr>
+        <p:style>
+          <a:lnRef idx="1">
+            <a:schemeClr val="accent1"/>
+          </a:lnRef>
+          <a:fillRef idx="3">
+            <a:schemeClr val="accent1"/>
+          </a:fillRef>
+          <a:effectRef idx="2">
+            <a:schemeClr val="accent1"/>
+          </a:effectRef>
+          <a:fontRef idx="minor">
+            <a:schemeClr val="lt1"/>
+          </a:fontRef>
+        </p:style>
+        <p:txBody>
+          <a:bodyPr rtlCol="0" anchor="ctr"/>
+          <a:lstStyle/>
+          <a:p>
+            <a:pPr algn="ctr"/>
+          </a:p>
+        </p:txBody>
+      </p:sp>
+      <p:sp>
+        <p:nvSpPr>
+          <p:cNvPr id="46" name="Rectangle 45"/>
+          <p:cNvSpPr/>
+          <p:nvPr/>
+        </p:nvSpPr>
+        <p:spPr>
+          <a:xfrm>
+            <a:off x="9052559" y="4864608"/>
+            <a:ext cx="54864" cy="1417320"/>
+          </a:xfrm>
+          <a:prstGeom prst="rect">
+            <a:avLst/>
+          </a:prstGeom>
+          <a:solidFill>
+            <a:srgbClr val="27AE60"/>
+          </a:solidFill>
+          <a:ln>
+            <a:noFill/>
+          </a:ln>
+        </p:spPr>
+        <p:style>
+          <a:lnRef idx="1">
+            <a:schemeClr val="accent1"/>
+          </a:lnRef>
+          <a:fillRef idx="3">
+            <a:schemeClr val="accent1"/>
+          </a:fillRef>
+          <a:effectRef idx="2">
+            <a:schemeClr val="accent1"/>
+          </a:effectRef>
+          <a:fontRef idx="minor">
+            <a:schemeClr val="lt1"/>
+          </a:fontRef>
+        </p:style>
+        <p:txBody>
+          <a:bodyPr rtlCol="0" anchor="ctr"/>
+          <a:lstStyle/>
+          <a:p>
+            <a:pPr algn="ctr"/>
+          </a:p>
+        </p:txBody>
+      </p:sp>
+      <p:sp>
+        <p:nvSpPr>
+          <p:cNvPr id="47" name="TextBox 46"/>
+          <p:cNvSpPr txBox="1"/>
+          <p:nvPr/>
+        </p:nvSpPr>
+        <p:spPr>
+          <a:xfrm>
+            <a:off x="9189719" y="4937760"/>
+            <a:ext cx="2651760" cy="384048"/>
+          </a:xfrm>
+          <a:prstGeom prst="rect">
+            <a:avLst/>
+          </a:prstGeom>
+          <a:noFill/>
+        </p:spPr>
+        <p:txBody>
+          <a:bodyPr wrap="square">
+            <a:spAutoFit/>
+          </a:bodyPr>
+          <a:lstStyle/>
+          <a:p>
+            <a:pPr algn="l"/>
+            <a:r>
+              <a:rPr sz="1100" b="1" i="0">
+                <a:solidFill>
+                  <a:srgbClr val="27AE60"/>
+                </a:solidFill>
+                <a:latin typeface="Calibri"/>
+              </a:rPr>
+              <a:t>patients_optimal</a:t>
+            </a:r>
+          </a:p>
+        </p:txBody>
+      </p:sp>
+      <p:sp>
+        <p:nvSpPr>
+          <p:cNvPr id="48" name="TextBox 47"/>
+          <p:cNvSpPr txBox="1"/>
+          <p:nvPr/>
+        </p:nvSpPr>
+        <p:spPr>
+          <a:xfrm>
+            <a:off x="9189719" y="5340096"/>
+            <a:ext cx="2651760" cy="320040"/>
+          </a:xfrm>
+          <a:prstGeom prst="rect">
+            <a:avLst/>
+          </a:prstGeom>
+          <a:noFill/>
+        </p:spPr>
+        <p:txBody>
+          <a:bodyPr wrap="square">
+            <a:spAutoFit/>
+          </a:bodyPr>
+          <a:lstStyle/>
+          <a:p>
+            <a:pPr algn="l"/>
+            <a:r>
+              <a:rPr sz="1000" b="0" i="0">
+                <a:solidFill>
+                  <a:srgbClr val="B2BEC3"/>
+                </a:solidFill>
+                <a:latin typeface="Calibri"/>
+              </a:rPr>
+              <a:t>🟢 Stable Patients</a:t>
+            </a:r>
+          </a:p>
+        </p:txBody>
+      </p:sp>
+      <p:sp>
+        <p:nvSpPr>
+          <p:cNvPr id="49" name="TextBox 48"/>
+          <p:cNvSpPr txBox="1"/>
+          <p:nvPr/>
+        </p:nvSpPr>
+        <p:spPr>
+          <a:xfrm>
+            <a:off x="9189719" y="5687568"/>
+            <a:ext cx="2651760" cy="320040"/>
+          </a:xfrm>
+          <a:prstGeom prst="rect">
+            <a:avLst/>
+          </a:prstGeom>
+          <a:noFill/>
+        </p:spPr>
+        <p:txBody>
+          <a:bodyPr wrap="square">
+            <a:spAutoFit/>
+          </a:bodyPr>
+          <a:lstStyle/>
+          <a:p>
+            <a:pPr algn="l"/>
+            <a:r>
+              <a:rPr sz="1100" b="1" i="0">
+                <a:solidFill>
+                  <a:srgbClr val="FFFFFF"/>
+                </a:solidFill>
+                <a:latin typeface="Calibri"/>
+              </a:rPr>
+              <a:t>~3,100 records</a:t>
+            </a:r>
+          </a:p>
+        </p:txBody>
+      </p:sp>
+      <p:sp>
+        <p:nvSpPr>
+          <p:cNvPr id="50" name="Rectangle 49"/>
+          <p:cNvSpPr/>
+          <p:nvPr/>
+        </p:nvSpPr>
+        <p:spPr>
+          <a:xfrm>
+            <a:off x="365760" y="4251960"/>
+            <a:ext cx="11430000" cy="960120"/>
+          </a:xfrm>
+          <a:prstGeom prst="rect">
+            <a:avLst/>
+          </a:prstGeom>
+          <a:solidFill>
+            <a:srgbClr val="11263A"/>
+          </a:solidFill>
+          <a:ln>
+            <a:noFill/>
+          </a:ln>
+        </p:spPr>
+        <p:style>
+          <a:lnRef idx="1">
+            <a:schemeClr val="accent1"/>
+          </a:lnRef>
+          <a:fillRef idx="3">
+            <a:schemeClr val="accent1"/>
+          </a:fillRef>
+          <a:effectRef idx="2">
+            <a:schemeClr val="accent1"/>
+          </a:effectRef>
+          <a:fontRef idx="minor">
+            <a:schemeClr val="lt1"/>
+          </a:fontRef>
+        </p:style>
+        <p:txBody>
+          <a:bodyPr rtlCol="0" anchor="ctr"/>
+          <a:lstStyle/>
+          <a:p>
+            <a:pPr algn="ctr"/>
+          </a:p>
+        </p:txBody>
+      </p:sp>
+      <p:sp>
+        <p:nvSpPr>
+          <p:cNvPr id="51" name="Rectangle 50"/>
+          <p:cNvSpPr/>
+          <p:nvPr/>
+        </p:nvSpPr>
+        <p:spPr>
+          <a:xfrm>
+            <a:off x="365760" y="4251960"/>
+            <a:ext cx="11430000" cy="54864"/>
+          </a:xfrm>
+          <a:prstGeom prst="rect">
+            <a:avLst/>
+          </a:prstGeom>
+          <a:solidFill>
+            <a:srgbClr val="E74C3C"/>
+          </a:solidFill>
+          <a:ln>
+            <a:noFill/>
+          </a:ln>
+        </p:spPr>
+        <p:style>
+          <a:lnRef idx="1">
+            <a:schemeClr val="accent1"/>
+          </a:lnRef>
+          <a:fillRef idx="3">
+            <a:schemeClr val="accent1"/>
+          </a:fillRef>
+          <a:effectRef idx="2">
+            <a:schemeClr val="accent1"/>
+          </a:effectRef>
+          <a:fontRef idx="minor">
+            <a:schemeClr val="lt1"/>
+          </a:fontRef>
+        </p:style>
+        <p:txBody>
+          <a:bodyPr rtlCol="0" anchor="ctr"/>
+          <a:lstStyle/>
+          <a:p>
+            <a:pPr algn="ctr"/>
+          </a:p>
+        </p:txBody>
+      </p:sp>
+      <p:sp>
+        <p:nvSpPr>
+          <p:cNvPr id="52" name="TextBox 51"/>
+          <p:cNvSpPr txBox="1"/>
+          <p:nvPr/>
+        </p:nvSpPr>
+        <p:spPr>
+          <a:xfrm>
+            <a:off x="502920" y="4315968"/>
+            <a:ext cx="9144000" cy="347472"/>
+          </a:xfrm>
+          <a:prstGeom prst="rect">
+            <a:avLst/>
+          </a:prstGeom>
+          <a:noFill/>
+        </p:spPr>
+        <p:txBody>
+          <a:bodyPr wrap="square">
+            <a:spAutoFit/>
+          </a:bodyPr>
+          <a:lstStyle/>
+          <a:p>
+            <a:pPr algn="l"/>
+            <a:r>
+              <a:rPr sz="1200" b="1" i="0">
+                <a:solidFill>
+                  <a:srgbClr val="FFFFFF"/>
+                </a:solidFill>
+                <a:latin typeface="Calibri"/>
+              </a:rPr>
+              <a:t>⚡ Partitioning Logic — runs on every save_diagnosis() call:</a:t>
+            </a:r>
+          </a:p>
+        </p:txBody>
+      </p:sp>
+      <p:sp>
+        <p:nvSpPr>
+          <p:cNvPr id="53" name="TextBox 52"/>
+          <p:cNvSpPr txBox="1"/>
+          <p:nvPr/>
+        </p:nvSpPr>
+        <p:spPr>
+          <a:xfrm>
+            <a:off x="502920" y="4681728"/>
+            <a:ext cx="11155680" cy="457200"/>
+          </a:xfrm>
+          <a:prstGeom prst="rect">
+            <a:avLst/>
+          </a:prstGeom>
+          <a:noFill/>
+        </p:spPr>
+        <p:txBody>
+          <a:bodyPr wrap="square">
+            <a:spAutoFit/>
+          </a:bodyPr>
+          <a:lstStyle/>
+          <a:p>
+            <a:pPr algn="l"/>
+            <a:r>
+              <a:rPr sz="1100" b="0" i="0">
+                <a:solidFill>
+                  <a:srgbClr val="00C9B1"/>
+                </a:solidFill>
+                <a:latin typeface="Calibri"/>
+              </a:rPr>
+              <a:t>if glucose &gt; 180 or hba1c &gt; 8.0  →  patients_critical   🔴     elif glucose &gt; 120 or hba1c &gt; 6.5  →  patients_monitoring 🟡     else  →  patients_optimal  🟢</a:t>
+            </a:r>
+          </a:p>
+        </p:txBody>
+      </p:sp>
+      <p:sp>
+        <p:nvSpPr>
+          <p:cNvPr id="54" name="TextBox 53"/>
+          <p:cNvSpPr txBox="1"/>
+          <p:nvPr/>
+        </p:nvSpPr>
+        <p:spPr>
+          <a:xfrm>
+            <a:off x="365760" y="5285232"/>
+            <a:ext cx="11430000" cy="347472"/>
+          </a:xfrm>
+          <a:prstGeom prst="rect">
+            <a:avLst/>
+          </a:prstGeom>
+          <a:noFill/>
+        </p:spPr>
+        <p:txBody>
+          <a:bodyPr wrap="square">
+            <a:spAutoFit/>
+          </a:bodyPr>
+          <a:lstStyle/>
+          <a:p>
+            <a:pPr algn="l"/>
+            <a:r>
+              <a:rPr sz="1100" b="0" i="1">
+                <a:solidFill>
+                  <a:srgbClr val="B2BEC3"/>
+                </a:solidFill>
+                <a:latin typeface="Calibri"/>
+              </a:rPr>
+              <a:t>patients fields: patient_ref (unique) | name | age | gender | phone | email | created_at</a:t>
+            </a:r>
+          </a:p>
+        </p:txBody>
+      </p:sp>
+      <p:sp>
+        <p:nvSpPr>
+          <p:cNvPr id="55" name="TextBox 54"/>
+          <p:cNvSpPr txBox="1"/>
+          <p:nvPr/>
+        </p:nvSpPr>
+        <p:spPr>
+          <a:xfrm>
+            <a:off x="365760" y="5650992"/>
+            <a:ext cx="11430000" cy="347472"/>
+          </a:xfrm>
+          <a:prstGeom prst="rect">
+            <a:avLst/>
+          </a:prstGeom>
+          <a:noFill/>
+        </p:spPr>
+        <p:txBody>
+          <a:bodyPr wrap="square">
+            <a:spAutoFit/>
+          </a:bodyPr>
+          <a:lstStyle/>
+          <a:p>
+            <a:pPr algn="l"/>
+            <a:r>
+              <a:rPr sz="1100" b="0" i="1">
+                <a:solidFill>
+                  <a:srgbClr val="B2BEC3"/>
+                </a:solidFill>
+                <a:latin typeface="Calibri"/>
+              </a:rPr>
+              <a:t>diagnoses fields: patient_ref | disease | prediction | confidence | risk_score | model_used | glucose | bp | bmi | hba1c | cholesterol | creatinine | created_at</a:t>
+            </a:r>
+          </a:p>
+        </p:txBody>
+      </p:sp>
+      <p:sp>
+        <p:nvSpPr>
+          <p:cNvPr id="56" name="Rectangle 55"/>
+          <p:cNvSpPr/>
+          <p:nvPr/>
+        </p:nvSpPr>
+        <p:spPr>
+          <a:xfrm>
+            <a:off x="0" y="6629400"/>
+            <a:ext cx="12188952" cy="228600"/>
+          </a:xfrm>
+          <a:prstGeom prst="rect">
+            <a:avLst/>
+          </a:prstGeom>
+          <a:solidFill>
+            <a:srgbClr val="11263A"/>
+          </a:solidFill>
+          <a:ln>
+            <a:noFill/>
+          </a:ln>
+        </p:spPr>
+        <p:style>
+          <a:lnRef idx="1">
+            <a:schemeClr val="accent1"/>
+          </a:lnRef>
+          <a:fillRef idx="3">
+            <a:schemeClr val="accent1"/>
+          </a:fillRef>
+          <a:effectRef idx="2">
+            <a:schemeClr val="accent1"/>
+          </a:effectRef>
+          <a:fontRef idx="minor">
+            <a:schemeClr val="lt1"/>
+          </a:fontRef>
+        </p:style>
+        <p:txBody>
+          <a:bodyPr rtlCol="0" anchor="ctr"/>
+          <a:lstStyle/>
+          <a:p>
+            <a:pPr algn="ctr"/>
+          </a:p>
+        </p:txBody>
+      </p:sp>
+      <p:sp>
+        <p:nvSpPr>
+          <p:cNvPr id="57" name="TextBox 56"/>
           <p:cNvSpPr txBox="1"/>
           <p:nvPr/>
         </p:nvSpPr>
@@ -27649,7 +28327,7 @@
       </p:sp>
       <p:sp>
         <p:nvSpPr>
-          <p:cNvPr id="45" name="TextBox 44"/>
+          <p:cNvPr id="58" name="TextBox 57"/>
           <p:cNvSpPr txBox="1"/>
           <p:nvPr/>
         </p:nvSpPr>
@@ -27684,7 +28362,7 @@
       </p:sp>
       <p:sp>
         <p:nvSpPr>
-          <p:cNvPr id="46" name="TextBox 45"/>
+          <p:cNvPr id="59" name="TextBox 58"/>
           <p:cNvSpPr txBox="1"/>
           <p:nvPr/>
         </p:nvSpPr>

</xml_diff>